<commit_message>
Add a soccer final-score example
Co-Authored-By: Claude Opus 5.5 <noreply@anthropic.com>
</commit_message>
<xml_diff>
--- a/templates/social/wildcats-social-posts.pptx
+++ b/templates/social/wildcats-social-posts.pptx
@@ -14,6 +14,7 @@
     <p:sldId id="262" r:id="rId14"/>
     <p:sldId id="263" r:id="rId15"/>
     <p:sldId id="264" r:id="rId16"/>
+    <p:sldId id="265" r:id="rId17"/>
   </p:sldIdLst>
   <p:sldSz cx="10287000" cy="12858750" type="screen4x3"/>
   <p:notesSz cx="6858000" cy="9144000"/>
@@ -535,6 +536,76 @@
 </p:notes>
 </file>
 
+<file path=ppt/notesSlides/notesSlide10.xml><?xml version="1.0" encoding="utf-8"?>
+<p:notes xmlns:a="http://schemas.openxmlformats.org/drawingml/2006/main" xmlns:p="http://schemas.openxmlformats.org/presentationml/2006/main" xmlns:r="http://schemas.openxmlformats.org/officeDocument/2006/relationships">
+  <p:cSld>
+    <p:spTree>
+      <p:nvGrpSpPr>
+        <p:cNvPr id="1" name=""/>
+        <p:cNvGrpSpPr/>
+        <p:nvPr/>
+      </p:nvGrpSpPr>
+      <p:grpSpPr>
+        <a:xfrm>
+          <a:off x="0" y="0"/>
+          <a:ext cx="0" cy="0"/>
+          <a:chOff x="0" y="0"/>
+          <a:chExt cx="0" cy="0"/>
+        </a:xfrm>
+      </p:grpSpPr>
+      <p:sp>
+        <p:nvSpPr>
+          <p:cNvPr id="2" name="Slide Image Placeholder 1"/>
+          <p:cNvSpPr>
+            <a:spLocks noGrp="1"/>
+          </p:cNvSpPr>
+          <p:nvPr>
+            <p:ph type="sldImg" idx="2"/>
+          </p:nvPr>
+        </p:nvSpPr>
+        <p:spPr/>
+      </p:sp>
+      <p:sp>
+        <p:nvSpPr>
+          <p:cNvPr id="3" name="Notes Placeholder 2"/>
+          <p:cNvSpPr>
+            <a:spLocks noGrp="1"/>
+          </p:cNvSpPr>
+          <p:nvPr>
+            <p:ph type="body" idx="3" sz="quarter"/>
+          </p:nvPr>
+        </p:nvSpPr>
+        <p:spPr/>
+        <p:txBody>
+          <a:bodyPr/>
+          <a:lstStyle/>
+          <a:p>
+            <a:r>
+              <a:t>Schedule: example</a:t>
+            </a:r>
+          </a:p>
+        </p:txBody>
+      </p:sp>
+      <p:sp>
+        <p:nvSpPr>
+          <p:cNvPr id="4" name="Slide Number Placeholder 3"/>
+          <p:cNvSpPr>
+            <a:spLocks noGrp="1"/>
+          </p:cNvSpPr>
+          <p:nvPr>
+            <p:ph type="sldNum" idx="5" sz="quarter"/>
+          </p:nvPr>
+        </p:nvSpPr>
+        <p:spPr/>
+      </p:sp>
+    </p:spTree>
+  </p:cSld>
+  <p:clrMapOvr>
+    <a:masterClrMapping/>
+  </p:clrMapOvr>
+</p:notes>
+</file>
+
 <file path=ppt/notesSlides/notesSlide2.xml><?xml version="1.0" encoding="utf-8"?>
 <p:notes xmlns:a="http://schemas.openxmlformats.org/drawingml/2006/main" xmlns:p="http://schemas.openxmlformats.org/presentationml/2006/main" xmlns:r="http://schemas.openxmlformats.org/officeDocument/2006/relationships">
   <p:cSld>
@@ -1000,7 +1071,7 @@
           <a:lstStyle/>
           <a:p>
             <a:r>
-              <a:t>Result: example-no-photo</a:t>
+              <a:t>Result: example-soccer</a:t>
             </a:r>
           </a:p>
         </p:txBody>
@@ -1070,7 +1141,7 @@
           <a:lstStyle/>
           <a:p>
             <a:r>
-              <a:t>Schedule: example</a:t>
+              <a:t>Result: example-no-photo</a:t>
             </a:r>
           </a:p>
         </p:txBody>
@@ -4438,6 +4509,1491 @@
 </p:sld>
 </file>
 
+<file path=ppt/slides/slide10.xml><?xml version="1.0" encoding="utf-8"?>
+<p:sld xmlns:a="http://schemas.openxmlformats.org/drawingml/2006/main" xmlns:p="http://schemas.openxmlformats.org/presentationml/2006/main" xmlns:r="http://schemas.openxmlformats.org/officeDocument/2006/relationships">
+  <p:cSld>
+    <p:spTree>
+      <p:nvGrpSpPr>
+        <p:cNvPr id="1" name=""/>
+        <p:cNvGrpSpPr/>
+        <p:nvPr/>
+      </p:nvGrpSpPr>
+      <p:grpSpPr/>
+      <p:sp>
+        <p:nvSpPr>
+          <p:cNvPr id="2" name="Background"/>
+          <p:cNvSpPr/>
+          <p:nvPr/>
+        </p:nvSpPr>
+        <p:spPr>
+          <a:xfrm>
+            <a:off x="0" y="0"/>
+            <a:ext cx="10287000" cy="12858750"/>
+          </a:xfrm>
+          <a:custGeom>
+            <a:avLst/>
+            <a:gdLst/>
+            <a:ahLst/>
+            <a:cxnLst/>
+            <a:rect l="l" t="t" r="r" b="b"/>
+            <a:pathLst>
+              <a:path w="10287000" h="12858750">
+                <a:moveTo>
+                  <a:pt x="0" y="0"/>
+                </a:moveTo>
+                <a:lnTo>
+                  <a:pt x="10287000" y="0"/>
+                </a:lnTo>
+                <a:lnTo>
+                  <a:pt x="10287000" y="12858750"/>
+                </a:lnTo>
+                <a:lnTo>
+                  <a:pt x="0" y="12858750"/>
+                </a:lnTo>
+                <a:lnTo>
+                  <a:pt x="0" y="0"/>
+                </a:lnTo>
+                <a:close/>
+              </a:path>
+            </a:pathLst>
+          </a:custGeom>
+          <a:solidFill>
+            <a:srgbClr val="5E1A1D"/>
+          </a:solidFill>
+          <a:ln>
+            <a:noFill/>
+          </a:ln>
+        </p:spPr>
+        <p:style>
+          <a:lnRef idx="1">
+            <a:schemeClr val="accent1"/>
+          </a:lnRef>
+          <a:fillRef idx="3">
+            <a:schemeClr val="accent1"/>
+          </a:fillRef>
+          <a:effectRef idx="2">
+            <a:schemeClr val="accent1"/>
+          </a:effectRef>
+          <a:fontRef idx="minor">
+            <a:schemeClr val="lt1"/>
+          </a:fontRef>
+        </p:style>
+        <p:txBody>
+          <a:bodyPr rtlCol="0" anchor="ctr"/>
+          <a:lstStyle/>
+          <a:p>
+            <a:pPr algn="ctr"/>
+          </a:p>
+        </p:txBody>
+      </p:sp>
+      <p:pic>
+        <p:nvPicPr>
+          <p:cNvPr id="3" name="Team logo" descr="image.png"/>
+          <p:cNvPicPr>
+            <a:picLocks noChangeAspect="1"/>
+          </p:cNvPicPr>
+          <p:nvPr/>
+        </p:nvPicPr>
+        <p:blipFill>
+          <a:blip r:embed="rId2"/>
+          <a:stretch>
+            <a:fillRect/>
+          </a:stretch>
+        </p:blipFill>
+        <p:spPr>
+          <a:xfrm>
+            <a:off x="685800" y="685800"/>
+            <a:ext cx="4785200" cy="723900"/>
+          </a:xfrm>
+          <a:prstGeom prst="rect">
+            <a:avLst/>
+          </a:prstGeom>
+        </p:spPr>
+      </p:pic>
+      <p:sp>
+        <p:nvSpPr>
+          <p:cNvPr id="4" name="Title"/>
+          <p:cNvSpPr txBox="1"/>
+          <p:nvPr/>
+        </p:nvSpPr>
+        <p:spPr>
+          <a:xfrm>
+            <a:off x="685800" y="1708880"/>
+            <a:ext cx="3284258" cy="529495"/>
+          </a:xfrm>
+          <a:prstGeom prst="rect">
+            <a:avLst/>
+          </a:prstGeom>
+          <a:noFill/>
+        </p:spPr>
+        <p:txBody>
+          <a:bodyPr wrap="none" lIns="0" rIns="0" tIns="0" bIns="0" anchor="t">
+            <a:spAutoFit/>
+          </a:bodyPr>
+          <a:lstStyle/>
+          <a:p>
+            <a:pPr algn="l"/>
+            <a:r>
+              <a:rPr sz="2550" b="1" spc="357" cap="all">
+                <a:solidFill>
+                  <a:srgbClr val="F5EAD5"/>
+                </a:solidFill>
+                <a:latin typeface="Saira"/>
+              </a:rPr>
+              <a:t>2026 SCHEDULE</a:t>
+            </a:r>
+          </a:p>
+        </p:txBody>
+      </p:sp>
+      <p:sp>
+        <p:nvSpPr>
+          <p:cNvPr id="5" name="Row 1 date panel"/>
+          <p:cNvSpPr/>
+          <p:nvPr/>
+        </p:nvSpPr>
+        <p:spPr>
+          <a:xfrm>
+            <a:off x="685800" y="2647950"/>
+            <a:ext cx="1509017" cy="716042"/>
+          </a:xfrm>
+          <a:custGeom>
+            <a:avLst/>
+            <a:gdLst/>
+            <a:ahLst/>
+            <a:cxnLst/>
+            <a:rect l="l" t="t" r="r" b="b"/>
+            <a:pathLst>
+              <a:path w="1509017" h="716042">
+                <a:moveTo>
+                  <a:pt x="85925" y="0"/>
+                </a:moveTo>
+                <a:lnTo>
+                  <a:pt x="1509017" y="0"/>
+                </a:lnTo>
+                <a:lnTo>
+                  <a:pt x="1423092" y="716042"/>
+                </a:lnTo>
+                <a:lnTo>
+                  <a:pt x="0" y="716042"/>
+                </a:lnTo>
+                <a:lnTo>
+                  <a:pt x="85925" y="0"/>
+                </a:lnTo>
+                <a:close/>
+              </a:path>
+            </a:pathLst>
+          </a:custGeom>
+          <a:solidFill>
+            <a:srgbClr val="F5EAD5"/>
+          </a:solidFill>
+          <a:ln>
+            <a:noFill/>
+          </a:ln>
+        </p:spPr>
+        <p:style>
+          <a:lnRef idx="1">
+            <a:schemeClr val="accent1"/>
+          </a:lnRef>
+          <a:fillRef idx="3">
+            <a:schemeClr val="accent1"/>
+          </a:fillRef>
+          <a:effectRef idx="2">
+            <a:schemeClr val="accent1"/>
+          </a:effectRef>
+          <a:fontRef idx="minor">
+            <a:schemeClr val="lt1"/>
+          </a:fontRef>
+        </p:style>
+        <p:txBody>
+          <a:bodyPr rtlCol="0" anchor="ctr"/>
+          <a:lstStyle/>
+          <a:p>
+            <a:pPr algn="ctr"/>
+          </a:p>
+        </p:txBody>
+      </p:sp>
+      <p:sp>
+        <p:nvSpPr>
+          <p:cNvPr id="6" name="Row 1 date"/>
+          <p:cNvSpPr txBox="1"/>
+          <p:nvPr/>
+        </p:nvSpPr>
+        <p:spPr>
+          <a:xfrm>
+            <a:off x="850490" y="2479097"/>
+            <a:ext cx="1303023" cy="1089050"/>
+          </a:xfrm>
+          <a:prstGeom prst="rect">
+            <a:avLst/>
+          </a:prstGeom>
+          <a:noFill/>
+        </p:spPr>
+        <p:txBody>
+          <a:bodyPr wrap="none" lIns="0" rIns="0" tIns="0" bIns="0" anchor="t">
+            <a:spAutoFit/>
+          </a:bodyPr>
+          <a:lstStyle/>
+          <a:p>
+            <a:pPr algn="l"/>
+            <a:r>
+              <a:rPr sz="5244" b="0" cap="all">
+                <a:solidFill>
+                  <a:srgbClr val="5E1A1D"/>
+                </a:solidFill>
+                <a:latin typeface="Saira Condensed Black"/>
+              </a:rPr>
+              <a:t>8/22</a:t>
+            </a:r>
+          </a:p>
+        </p:txBody>
+      </p:sp>
+      <p:sp>
+        <p:nvSpPr>
+          <p:cNvPr id="7" name="Row 1 opponent"/>
+          <p:cNvSpPr txBox="1"/>
+          <p:nvPr/>
+        </p:nvSpPr>
+        <p:spPr>
+          <a:xfrm>
+            <a:off x="2615915" y="2704600"/>
+            <a:ext cx="2447300" cy="622935"/>
+          </a:xfrm>
+          <a:prstGeom prst="rect">
+            <a:avLst/>
+          </a:prstGeom>
+          <a:noFill/>
+        </p:spPr>
+        <p:txBody>
+          <a:bodyPr wrap="none" lIns="0" rIns="0" tIns="0" bIns="0" anchor="t">
+            <a:spAutoFit/>
+          </a:bodyPr>
+          <a:lstStyle/>
+          <a:p>
+            <a:pPr algn="l"/>
+            <a:r>
+              <a:rPr sz="3000" b="1">
+                <a:solidFill>
+                  <a:srgbClr val="F5EAD5"/>
+                </a:solidFill>
+                <a:latin typeface="Saira"/>
+              </a:rPr>
+              <a:t>vs. Abbeville</a:t>
+            </a:r>
+          </a:p>
+        </p:txBody>
+      </p:sp>
+      <p:sp>
+        <p:nvSpPr>
+          <p:cNvPr id="8" name="Row 1 time"/>
+          <p:cNvSpPr txBox="1"/>
+          <p:nvPr/>
+        </p:nvSpPr>
+        <p:spPr>
+          <a:xfrm>
+            <a:off x="8718691" y="2719668"/>
+            <a:ext cx="882509" cy="591788"/>
+          </a:xfrm>
+          <a:prstGeom prst="rect">
+            <a:avLst/>
+          </a:prstGeom>
+          <a:noFill/>
+        </p:spPr>
+        <p:txBody>
+          <a:bodyPr wrap="none" lIns="0" rIns="0" tIns="0" bIns="0" anchor="t">
+            <a:spAutoFit/>
+          </a:bodyPr>
+          <a:lstStyle/>
+          <a:p>
+            <a:pPr algn="r"/>
+            <a:r>
+              <a:rPr sz="2850" b="1">
+                <a:solidFill>
+                  <a:srgbClr val="F5EAD5"/>
+                </a:solidFill>
+                <a:latin typeface="Saira"/>
+              </a:rPr>
+              <a:t>7:30</a:t>
+            </a:r>
+          </a:p>
+        </p:txBody>
+      </p:sp>
+      <p:sp>
+        <p:nvSpPr>
+          <p:cNvPr id="9" name="Row 2 date panel"/>
+          <p:cNvSpPr/>
+          <p:nvPr/>
+        </p:nvSpPr>
+        <p:spPr>
+          <a:xfrm>
+            <a:off x="685800" y="3802856"/>
+            <a:ext cx="1521672" cy="716042"/>
+          </a:xfrm>
+          <a:custGeom>
+            <a:avLst/>
+            <a:gdLst/>
+            <a:ahLst/>
+            <a:cxnLst/>
+            <a:rect l="l" t="t" r="r" b="b"/>
+            <a:pathLst>
+              <a:path w="1521672" h="716042">
+                <a:moveTo>
+                  <a:pt x="85925" y="0"/>
+                </a:moveTo>
+                <a:lnTo>
+                  <a:pt x="1521672" y="0"/>
+                </a:lnTo>
+                <a:lnTo>
+                  <a:pt x="1435747" y="716042"/>
+                </a:lnTo>
+                <a:lnTo>
+                  <a:pt x="0" y="716042"/>
+                </a:lnTo>
+                <a:lnTo>
+                  <a:pt x="85925" y="0"/>
+                </a:lnTo>
+                <a:close/>
+              </a:path>
+            </a:pathLst>
+          </a:custGeom>
+          <a:solidFill>
+            <a:srgbClr val="F5EAD5"/>
+          </a:solidFill>
+          <a:ln>
+            <a:noFill/>
+          </a:ln>
+        </p:spPr>
+        <p:style>
+          <a:lnRef idx="1">
+            <a:schemeClr val="accent1"/>
+          </a:lnRef>
+          <a:fillRef idx="3">
+            <a:schemeClr val="accent1"/>
+          </a:fillRef>
+          <a:effectRef idx="2">
+            <a:schemeClr val="accent1"/>
+          </a:effectRef>
+          <a:fontRef idx="minor">
+            <a:schemeClr val="lt1"/>
+          </a:fontRef>
+        </p:style>
+        <p:txBody>
+          <a:bodyPr rtlCol="0" anchor="ctr"/>
+          <a:lstStyle/>
+          <a:p>
+            <a:pPr algn="ctr"/>
+          </a:p>
+        </p:txBody>
+      </p:sp>
+      <p:sp>
+        <p:nvSpPr>
+          <p:cNvPr id="10" name="Row 2 date"/>
+          <p:cNvSpPr txBox="1"/>
+          <p:nvPr/>
+        </p:nvSpPr>
+        <p:spPr>
+          <a:xfrm>
+            <a:off x="850490" y="3634004"/>
+            <a:ext cx="1316185" cy="1089050"/>
+          </a:xfrm>
+          <a:prstGeom prst="rect">
+            <a:avLst/>
+          </a:prstGeom>
+          <a:noFill/>
+        </p:spPr>
+        <p:txBody>
+          <a:bodyPr wrap="none" lIns="0" rIns="0" tIns="0" bIns="0" anchor="t">
+            <a:spAutoFit/>
+          </a:bodyPr>
+          <a:lstStyle/>
+          <a:p>
+            <a:pPr algn="l"/>
+            <a:r>
+              <a:rPr sz="5244" b="0" cap="all">
+                <a:solidFill>
+                  <a:srgbClr val="5E1A1D"/>
+                </a:solidFill>
+                <a:latin typeface="Saira Condensed Black"/>
+              </a:rPr>
+              <a:t>8/29</a:t>
+            </a:r>
+          </a:p>
+        </p:txBody>
+      </p:sp>
+      <p:sp>
+        <p:nvSpPr>
+          <p:cNvPr id="11" name="Row 2 opponent"/>
+          <p:cNvSpPr txBox="1"/>
+          <p:nvPr/>
+        </p:nvSpPr>
+        <p:spPr>
+          <a:xfrm>
+            <a:off x="2615915" y="3859506"/>
+            <a:ext cx="6111728" cy="622935"/>
+          </a:xfrm>
+          <a:prstGeom prst="rect">
+            <a:avLst/>
+          </a:prstGeom>
+          <a:noFill/>
+        </p:spPr>
+        <p:txBody>
+          <a:bodyPr wrap="none" lIns="0" rIns="0" tIns="0" bIns="0" anchor="t">
+            <a:spAutoFit/>
+          </a:bodyPr>
+          <a:lstStyle/>
+          <a:p>
+            <a:pPr algn="l"/>
+            <a:r>
+              <a:rPr sz="3000" b="1">
+                <a:solidFill>
+                  <a:srgbClr val="F5EAD5"/>
+                </a:solidFill>
+                <a:latin typeface="Saira"/>
+              </a:rPr>
+              <a:t>at Westwood Christian Academy</a:t>
+            </a:r>
+          </a:p>
+        </p:txBody>
+      </p:sp>
+      <p:sp>
+        <p:nvSpPr>
+          <p:cNvPr id="12" name="Row 2 time"/>
+          <p:cNvSpPr txBox="1"/>
+          <p:nvPr/>
+        </p:nvSpPr>
+        <p:spPr>
+          <a:xfrm>
+            <a:off x="8697988" y="3874575"/>
+            <a:ext cx="903212" cy="591788"/>
+          </a:xfrm>
+          <a:prstGeom prst="rect">
+            <a:avLst/>
+          </a:prstGeom>
+          <a:noFill/>
+        </p:spPr>
+        <p:txBody>
+          <a:bodyPr wrap="none" lIns="0" rIns="0" tIns="0" bIns="0" anchor="t">
+            <a:spAutoFit/>
+          </a:bodyPr>
+          <a:lstStyle/>
+          <a:p>
+            <a:pPr algn="r"/>
+            <a:r>
+              <a:rPr sz="2850" b="1">
+                <a:solidFill>
+                  <a:srgbClr val="F5EAD5"/>
+                </a:solidFill>
+                <a:latin typeface="Saira"/>
+              </a:rPr>
+              <a:t>7:00</a:t>
+            </a:r>
+          </a:p>
+        </p:txBody>
+      </p:sp>
+      <p:sp>
+        <p:nvSpPr>
+          <p:cNvPr id="13" name="Row 3 date panel"/>
+          <p:cNvSpPr/>
+          <p:nvPr/>
+        </p:nvSpPr>
+        <p:spPr>
+          <a:xfrm>
+            <a:off x="685800" y="4957762"/>
+            <a:ext cx="1195957" cy="716042"/>
+          </a:xfrm>
+          <a:custGeom>
+            <a:avLst/>
+            <a:gdLst/>
+            <a:ahLst/>
+            <a:cxnLst/>
+            <a:rect l="l" t="t" r="r" b="b"/>
+            <a:pathLst>
+              <a:path w="1195957" h="716042">
+                <a:moveTo>
+                  <a:pt x="85925" y="0"/>
+                </a:moveTo>
+                <a:lnTo>
+                  <a:pt x="1195957" y="0"/>
+                </a:lnTo>
+                <a:lnTo>
+                  <a:pt x="1110031" y="716042"/>
+                </a:lnTo>
+                <a:lnTo>
+                  <a:pt x="0" y="716042"/>
+                </a:lnTo>
+                <a:lnTo>
+                  <a:pt x="85925" y="0"/>
+                </a:lnTo>
+                <a:close/>
+              </a:path>
+            </a:pathLst>
+          </a:custGeom>
+          <a:solidFill>
+            <a:srgbClr val="F5EAD5"/>
+          </a:solidFill>
+          <a:ln>
+            <a:noFill/>
+          </a:ln>
+        </p:spPr>
+        <p:style>
+          <a:lnRef idx="1">
+            <a:schemeClr val="accent1"/>
+          </a:lnRef>
+          <a:fillRef idx="3">
+            <a:schemeClr val="accent1"/>
+          </a:fillRef>
+          <a:effectRef idx="2">
+            <a:schemeClr val="accent1"/>
+          </a:effectRef>
+          <a:fontRef idx="minor">
+            <a:schemeClr val="lt1"/>
+          </a:fontRef>
+        </p:style>
+        <p:txBody>
+          <a:bodyPr rtlCol="0" anchor="ctr"/>
+          <a:lstStyle/>
+          <a:p>
+            <a:pPr algn="ctr"/>
+          </a:p>
+        </p:txBody>
+      </p:sp>
+      <p:sp>
+        <p:nvSpPr>
+          <p:cNvPr id="14" name="Row 3 date"/>
+          <p:cNvSpPr txBox="1"/>
+          <p:nvPr/>
+        </p:nvSpPr>
+        <p:spPr>
+          <a:xfrm>
+            <a:off x="850490" y="4788910"/>
+            <a:ext cx="977440" cy="1089050"/>
+          </a:xfrm>
+          <a:prstGeom prst="rect">
+            <a:avLst/>
+          </a:prstGeom>
+          <a:noFill/>
+        </p:spPr>
+        <p:txBody>
+          <a:bodyPr wrap="none" lIns="0" rIns="0" tIns="0" bIns="0" anchor="t">
+            <a:spAutoFit/>
+          </a:bodyPr>
+          <a:lstStyle/>
+          <a:p>
+            <a:pPr algn="l"/>
+            <a:r>
+              <a:rPr sz="5244" b="0" cap="all">
+                <a:solidFill>
+                  <a:srgbClr val="5E1A1D"/>
+                </a:solidFill>
+                <a:latin typeface="Saira Condensed Black"/>
+              </a:rPr>
+              <a:t>9/5</a:t>
+            </a:r>
+          </a:p>
+        </p:txBody>
+      </p:sp>
+      <p:sp>
+        <p:nvSpPr>
+          <p:cNvPr id="15" name="Row 3 opponent"/>
+          <p:cNvSpPr txBox="1"/>
+          <p:nvPr/>
+        </p:nvSpPr>
+        <p:spPr>
+          <a:xfrm>
+            <a:off x="2615915" y="5014412"/>
+            <a:ext cx="1982907" cy="622935"/>
+          </a:xfrm>
+          <a:prstGeom prst="rect">
+            <a:avLst/>
+          </a:prstGeom>
+          <a:noFill/>
+        </p:spPr>
+        <p:txBody>
+          <a:bodyPr wrap="none" lIns="0" rIns="0" tIns="0" bIns="0" anchor="t">
+            <a:spAutoFit/>
+          </a:bodyPr>
+          <a:lstStyle/>
+          <a:p>
+            <a:pPr algn="l"/>
+            <a:r>
+              <a:rPr sz="3000" b="1">
+                <a:solidFill>
+                  <a:srgbClr val="F5EAD5"/>
+                </a:solidFill>
+                <a:latin typeface="Saira"/>
+              </a:rPr>
+              <a:t>vs. Saluda</a:t>
+            </a:r>
+          </a:p>
+        </p:txBody>
+      </p:sp>
+      <p:sp>
+        <p:nvSpPr>
+          <p:cNvPr id="16" name="Row 3 time"/>
+          <p:cNvSpPr txBox="1"/>
+          <p:nvPr/>
+        </p:nvSpPr>
+        <p:spPr>
+          <a:xfrm>
+            <a:off x="8718691" y="5029481"/>
+            <a:ext cx="882509" cy="591788"/>
+          </a:xfrm>
+          <a:prstGeom prst="rect">
+            <a:avLst/>
+          </a:prstGeom>
+          <a:noFill/>
+        </p:spPr>
+        <p:txBody>
+          <a:bodyPr wrap="none" lIns="0" rIns="0" tIns="0" bIns="0" anchor="t">
+            <a:spAutoFit/>
+          </a:bodyPr>
+          <a:lstStyle/>
+          <a:p>
+            <a:pPr algn="r"/>
+            <a:r>
+              <a:rPr sz="2850" b="1">
+                <a:solidFill>
+                  <a:srgbClr val="F5EAD5"/>
+                </a:solidFill>
+                <a:latin typeface="Saira"/>
+              </a:rPr>
+              <a:t>7:30</a:t>
+            </a:r>
+          </a:p>
+        </p:txBody>
+      </p:sp>
+      <p:sp>
+        <p:nvSpPr>
+          <p:cNvPr id="17" name="Row 4 date panel"/>
+          <p:cNvSpPr/>
+          <p:nvPr/>
+        </p:nvSpPr>
+        <p:spPr>
+          <a:xfrm>
+            <a:off x="685800" y="6112669"/>
+            <a:ext cx="1409770" cy="716042"/>
+          </a:xfrm>
+          <a:custGeom>
+            <a:avLst/>
+            <a:gdLst/>
+            <a:ahLst/>
+            <a:cxnLst/>
+            <a:rect l="l" t="t" r="r" b="b"/>
+            <a:pathLst>
+              <a:path w="1409770" h="716042">
+                <a:moveTo>
+                  <a:pt x="85925" y="0"/>
+                </a:moveTo>
+                <a:lnTo>
+                  <a:pt x="1409770" y="0"/>
+                </a:lnTo>
+                <a:lnTo>
+                  <a:pt x="1323845" y="716042"/>
+                </a:lnTo>
+                <a:lnTo>
+                  <a:pt x="0" y="716042"/>
+                </a:lnTo>
+                <a:lnTo>
+                  <a:pt x="85925" y="0"/>
+                </a:lnTo>
+                <a:close/>
+              </a:path>
+            </a:pathLst>
+          </a:custGeom>
+          <a:solidFill>
+            <a:srgbClr val="F5EAD5"/>
+          </a:solidFill>
+          <a:ln>
+            <a:noFill/>
+          </a:ln>
+        </p:spPr>
+        <p:style>
+          <a:lnRef idx="1">
+            <a:schemeClr val="accent1"/>
+          </a:lnRef>
+          <a:fillRef idx="3">
+            <a:schemeClr val="accent1"/>
+          </a:fillRef>
+          <a:effectRef idx="2">
+            <a:schemeClr val="accent1"/>
+          </a:effectRef>
+          <a:fontRef idx="minor">
+            <a:schemeClr val="lt1"/>
+          </a:fontRef>
+        </p:style>
+        <p:txBody>
+          <a:bodyPr rtlCol="0" anchor="ctr"/>
+          <a:lstStyle/>
+          <a:p>
+            <a:pPr algn="ctr"/>
+          </a:p>
+        </p:txBody>
+      </p:sp>
+      <p:sp>
+        <p:nvSpPr>
+          <p:cNvPr id="18" name="Row 4 date"/>
+          <p:cNvSpPr txBox="1"/>
+          <p:nvPr/>
+        </p:nvSpPr>
+        <p:spPr>
+          <a:xfrm>
+            <a:off x="850490" y="5943816"/>
+            <a:ext cx="1199806" cy="1089050"/>
+          </a:xfrm>
+          <a:prstGeom prst="rect">
+            <a:avLst/>
+          </a:prstGeom>
+          <a:noFill/>
+        </p:spPr>
+        <p:txBody>
+          <a:bodyPr wrap="none" lIns="0" rIns="0" tIns="0" bIns="0" anchor="t">
+            <a:spAutoFit/>
+          </a:bodyPr>
+          <a:lstStyle/>
+          <a:p>
+            <a:pPr algn="l"/>
+            <a:r>
+              <a:rPr sz="5244" b="0" cap="all">
+                <a:solidFill>
+                  <a:srgbClr val="5E1A1D"/>
+                </a:solidFill>
+                <a:latin typeface="Saira Condensed Black"/>
+              </a:rPr>
+              <a:t>9/12</a:t>
+            </a:r>
+          </a:p>
+        </p:txBody>
+      </p:sp>
+      <p:sp>
+        <p:nvSpPr>
+          <p:cNvPr id="19" name="Row 4 opponent"/>
+          <p:cNvSpPr txBox="1"/>
+          <p:nvPr/>
+        </p:nvSpPr>
+        <p:spPr>
+          <a:xfrm>
+            <a:off x="2615915" y="6169319"/>
+            <a:ext cx="2584003" cy="622935"/>
+          </a:xfrm>
+          <a:prstGeom prst="rect">
+            <a:avLst/>
+          </a:prstGeom>
+          <a:noFill/>
+        </p:spPr>
+        <p:txBody>
+          <a:bodyPr wrap="none" lIns="0" rIns="0" tIns="0" bIns="0" anchor="t">
+            <a:spAutoFit/>
+          </a:bodyPr>
+          <a:lstStyle/>
+          <a:p>
+            <a:pPr algn="l"/>
+            <a:r>
+              <a:rPr sz="3000" b="1">
+                <a:solidFill>
+                  <a:srgbClr val="F5EAD5"/>
+                </a:solidFill>
+                <a:latin typeface="Saira"/>
+              </a:rPr>
+              <a:t>at McCormick</a:t>
+            </a:r>
+          </a:p>
+        </p:txBody>
+      </p:sp>
+      <p:sp>
+        <p:nvSpPr>
+          <p:cNvPr id="20" name="Row 4 time"/>
+          <p:cNvSpPr txBox="1"/>
+          <p:nvPr/>
+        </p:nvSpPr>
+        <p:spPr>
+          <a:xfrm>
+            <a:off x="8718691" y="6184387"/>
+            <a:ext cx="882509" cy="591788"/>
+          </a:xfrm>
+          <a:prstGeom prst="rect">
+            <a:avLst/>
+          </a:prstGeom>
+          <a:noFill/>
+        </p:spPr>
+        <p:txBody>
+          <a:bodyPr wrap="none" lIns="0" rIns="0" tIns="0" bIns="0" anchor="t">
+            <a:spAutoFit/>
+          </a:bodyPr>
+          <a:lstStyle/>
+          <a:p>
+            <a:pPr algn="r"/>
+            <a:r>
+              <a:rPr sz="2850" b="1">
+                <a:solidFill>
+                  <a:srgbClr val="F5EAD5"/>
+                </a:solidFill>
+                <a:latin typeface="Saira"/>
+              </a:rPr>
+              <a:t>7:30</a:t>
+            </a:r>
+          </a:p>
+        </p:txBody>
+      </p:sp>
+      <p:sp>
+        <p:nvSpPr>
+          <p:cNvPr id="21" name="Row 5 date panel"/>
+          <p:cNvSpPr/>
+          <p:nvPr/>
+        </p:nvSpPr>
+        <p:spPr>
+          <a:xfrm>
+            <a:off x="685800" y="7267575"/>
+            <a:ext cx="1422426" cy="716042"/>
+          </a:xfrm>
+          <a:custGeom>
+            <a:avLst/>
+            <a:gdLst/>
+            <a:ahLst/>
+            <a:cxnLst/>
+            <a:rect l="l" t="t" r="r" b="b"/>
+            <a:pathLst>
+              <a:path w="1422426" h="716042">
+                <a:moveTo>
+                  <a:pt x="85925" y="0"/>
+                </a:moveTo>
+                <a:lnTo>
+                  <a:pt x="1422426" y="0"/>
+                </a:lnTo>
+                <a:lnTo>
+                  <a:pt x="1336501" y="716042"/>
+                </a:lnTo>
+                <a:lnTo>
+                  <a:pt x="0" y="716042"/>
+                </a:lnTo>
+                <a:lnTo>
+                  <a:pt x="85925" y="0"/>
+                </a:lnTo>
+                <a:close/>
+              </a:path>
+            </a:pathLst>
+          </a:custGeom>
+          <a:solidFill>
+            <a:srgbClr val="F5EAD5"/>
+          </a:solidFill>
+          <a:ln>
+            <a:noFill/>
+          </a:ln>
+        </p:spPr>
+        <p:style>
+          <a:lnRef idx="1">
+            <a:schemeClr val="accent1"/>
+          </a:lnRef>
+          <a:fillRef idx="3">
+            <a:schemeClr val="accent1"/>
+          </a:fillRef>
+          <a:effectRef idx="2">
+            <a:schemeClr val="accent1"/>
+          </a:effectRef>
+          <a:fontRef idx="minor">
+            <a:schemeClr val="lt1"/>
+          </a:fontRef>
+        </p:style>
+        <p:txBody>
+          <a:bodyPr rtlCol="0" anchor="ctr"/>
+          <a:lstStyle/>
+          <a:p>
+            <a:pPr algn="ctr"/>
+          </a:p>
+        </p:txBody>
+      </p:sp>
+      <p:sp>
+        <p:nvSpPr>
+          <p:cNvPr id="22" name="Row 5 date"/>
+          <p:cNvSpPr txBox="1"/>
+          <p:nvPr/>
+        </p:nvSpPr>
+        <p:spPr>
+          <a:xfrm>
+            <a:off x="850490" y="7098722"/>
+            <a:ext cx="1212968" cy="1089050"/>
+          </a:xfrm>
+          <a:prstGeom prst="rect">
+            <a:avLst/>
+          </a:prstGeom>
+          <a:noFill/>
+        </p:spPr>
+        <p:txBody>
+          <a:bodyPr wrap="none" lIns="0" rIns="0" tIns="0" bIns="0" anchor="t">
+            <a:spAutoFit/>
+          </a:bodyPr>
+          <a:lstStyle/>
+          <a:p>
+            <a:pPr algn="l"/>
+            <a:r>
+              <a:rPr sz="5244" b="0" cap="all">
+                <a:solidFill>
+                  <a:srgbClr val="5E1A1D"/>
+                </a:solidFill>
+                <a:latin typeface="Saira Condensed Black"/>
+              </a:rPr>
+              <a:t>9/19</a:t>
+            </a:r>
+          </a:p>
+        </p:txBody>
+      </p:sp>
+      <p:sp>
+        <p:nvSpPr>
+          <p:cNvPr id="23" name="Row 5 opponent"/>
+          <p:cNvSpPr txBox="1"/>
+          <p:nvPr/>
+        </p:nvSpPr>
+        <p:spPr>
+          <a:xfrm>
+            <a:off x="2615915" y="7324225"/>
+            <a:ext cx="5921929" cy="622935"/>
+          </a:xfrm>
+          <a:prstGeom prst="rect">
+            <a:avLst/>
+          </a:prstGeom>
+          <a:noFill/>
+        </p:spPr>
+        <p:txBody>
+          <a:bodyPr wrap="none" lIns="0" rIns="0" tIns="0" bIns="0" anchor="t">
+            <a:spAutoFit/>
+          </a:bodyPr>
+          <a:lstStyle/>
+          <a:p>
+            <a:pPr algn="l"/>
+            <a:r>
+              <a:rPr sz="3000" b="1">
+                <a:solidFill>
+                  <a:srgbClr val="F5EAD5"/>
+                </a:solidFill>
+                <a:latin typeface="Saira"/>
+              </a:rPr>
+              <a:t>vs. Greenwood Christian School</a:t>
+            </a:r>
+          </a:p>
+        </p:txBody>
+      </p:sp>
+      <p:sp>
+        <p:nvSpPr>
+          <p:cNvPr id="24" name="Row 5 time"/>
+          <p:cNvSpPr txBox="1"/>
+          <p:nvPr/>
+        </p:nvSpPr>
+        <p:spPr>
+          <a:xfrm>
+            <a:off x="8718691" y="7339293"/>
+            <a:ext cx="882509" cy="591788"/>
+          </a:xfrm>
+          <a:prstGeom prst="rect">
+            <a:avLst/>
+          </a:prstGeom>
+          <a:noFill/>
+        </p:spPr>
+        <p:txBody>
+          <a:bodyPr wrap="none" lIns="0" rIns="0" tIns="0" bIns="0" anchor="t">
+            <a:spAutoFit/>
+          </a:bodyPr>
+          <a:lstStyle/>
+          <a:p>
+            <a:pPr algn="r"/>
+            <a:r>
+              <a:rPr sz="2850" b="1">
+                <a:solidFill>
+                  <a:srgbClr val="F5EAD5"/>
+                </a:solidFill>
+                <a:latin typeface="Saira"/>
+              </a:rPr>
+              <a:t>7:30</a:t>
+            </a:r>
+          </a:p>
+        </p:txBody>
+      </p:sp>
+      <p:sp>
+        <p:nvSpPr>
+          <p:cNvPr id="25" name="Row 6 date panel"/>
+          <p:cNvSpPr/>
+          <p:nvPr/>
+        </p:nvSpPr>
+        <p:spPr>
+          <a:xfrm>
+            <a:off x="685800" y="8422481"/>
+            <a:ext cx="1513013" cy="716042"/>
+          </a:xfrm>
+          <a:custGeom>
+            <a:avLst/>
+            <a:gdLst/>
+            <a:ahLst/>
+            <a:cxnLst/>
+            <a:rect l="l" t="t" r="r" b="b"/>
+            <a:pathLst>
+              <a:path w="1513013" h="716042">
+                <a:moveTo>
+                  <a:pt x="85925" y="0"/>
+                </a:moveTo>
+                <a:lnTo>
+                  <a:pt x="1513013" y="0"/>
+                </a:lnTo>
+                <a:lnTo>
+                  <a:pt x="1427088" y="716042"/>
+                </a:lnTo>
+                <a:lnTo>
+                  <a:pt x="0" y="716042"/>
+                </a:lnTo>
+                <a:lnTo>
+                  <a:pt x="85925" y="0"/>
+                </a:lnTo>
+                <a:close/>
+              </a:path>
+            </a:pathLst>
+          </a:custGeom>
+          <a:solidFill>
+            <a:srgbClr val="320B0B"/>
+          </a:solidFill>
+          <a:ln>
+            <a:noFill/>
+          </a:ln>
+        </p:spPr>
+        <p:style>
+          <a:lnRef idx="1">
+            <a:schemeClr val="accent1"/>
+          </a:lnRef>
+          <a:fillRef idx="3">
+            <a:schemeClr val="accent1"/>
+          </a:fillRef>
+          <a:effectRef idx="2">
+            <a:schemeClr val="accent1"/>
+          </a:effectRef>
+          <a:fontRef idx="minor">
+            <a:schemeClr val="lt1"/>
+          </a:fontRef>
+        </p:style>
+        <p:txBody>
+          <a:bodyPr rtlCol="0" anchor="ctr"/>
+          <a:lstStyle/>
+          <a:p>
+            <a:pPr algn="ctr"/>
+          </a:p>
+        </p:txBody>
+      </p:sp>
+      <p:sp>
+        <p:nvSpPr>
+          <p:cNvPr id="26" name="Row 6 date"/>
+          <p:cNvSpPr txBox="1"/>
+          <p:nvPr/>
+        </p:nvSpPr>
+        <p:spPr>
+          <a:xfrm>
+            <a:off x="850490" y="8253629"/>
+            <a:ext cx="1307179" cy="1089050"/>
+          </a:xfrm>
+          <a:prstGeom prst="rect">
+            <a:avLst/>
+          </a:prstGeom>
+          <a:noFill/>
+        </p:spPr>
+        <p:txBody>
+          <a:bodyPr wrap="none" lIns="0" rIns="0" tIns="0" bIns="0" anchor="t">
+            <a:spAutoFit/>
+          </a:bodyPr>
+          <a:lstStyle/>
+          <a:p>
+            <a:pPr algn="l"/>
+            <a:r>
+              <a:rPr sz="5244" b="0" cap="all">
+                <a:solidFill>
+                  <a:srgbClr val="EBD9C6"/>
+                </a:solidFill>
+                <a:latin typeface="Saira Condensed Black"/>
+              </a:rPr>
+              <a:t>9/26</a:t>
+            </a:r>
+          </a:p>
+        </p:txBody>
+      </p:sp>
+      <p:sp>
+        <p:nvSpPr>
+          <p:cNvPr id="27" name="Row 6 opponent"/>
+          <p:cNvSpPr txBox="1"/>
+          <p:nvPr/>
+        </p:nvSpPr>
+        <p:spPr>
+          <a:xfrm>
+            <a:off x="2615915" y="8479131"/>
+            <a:ext cx="1975775" cy="622935"/>
+          </a:xfrm>
+          <a:prstGeom prst="rect">
+            <a:avLst/>
+          </a:prstGeom>
+          <a:noFill/>
+        </p:spPr>
+        <p:txBody>
+          <a:bodyPr wrap="none" lIns="0" rIns="0" tIns="0" bIns="0" anchor="t">
+            <a:spAutoFit/>
+          </a:bodyPr>
+          <a:lstStyle/>
+          <a:p>
+            <a:pPr algn="l"/>
+            <a:r>
+              <a:rPr sz="3000" b="1">
+                <a:solidFill>
+                  <a:srgbClr val="EBD9C6"/>
+                </a:solidFill>
+                <a:latin typeface="Saira"/>
+              </a:rPr>
+              <a:t>Open date</a:t>
+            </a:r>
+          </a:p>
+        </p:txBody>
+      </p:sp>
+      <p:sp>
+        <p:nvSpPr>
+          <p:cNvPr id="28" name="Row 7 date panel"/>
+          <p:cNvSpPr/>
+          <p:nvPr/>
+        </p:nvSpPr>
+        <p:spPr>
+          <a:xfrm>
+            <a:off x="685800" y="9577388"/>
+            <a:ext cx="1403109" cy="716042"/>
+          </a:xfrm>
+          <a:custGeom>
+            <a:avLst/>
+            <a:gdLst/>
+            <a:ahLst/>
+            <a:cxnLst/>
+            <a:rect l="l" t="t" r="r" b="b"/>
+            <a:pathLst>
+              <a:path w="1403109" h="716042">
+                <a:moveTo>
+                  <a:pt x="85925" y="0"/>
+                </a:moveTo>
+                <a:lnTo>
+                  <a:pt x="1403109" y="0"/>
+                </a:lnTo>
+                <a:lnTo>
+                  <a:pt x="1317184" y="716042"/>
+                </a:lnTo>
+                <a:lnTo>
+                  <a:pt x="0" y="716042"/>
+                </a:lnTo>
+                <a:lnTo>
+                  <a:pt x="85925" y="0"/>
+                </a:lnTo>
+                <a:close/>
+              </a:path>
+            </a:pathLst>
+          </a:custGeom>
+          <a:solidFill>
+            <a:srgbClr val="F5EAD5"/>
+          </a:solidFill>
+          <a:ln>
+            <a:noFill/>
+          </a:ln>
+        </p:spPr>
+        <p:style>
+          <a:lnRef idx="1">
+            <a:schemeClr val="accent1"/>
+          </a:lnRef>
+          <a:fillRef idx="3">
+            <a:schemeClr val="accent1"/>
+          </a:fillRef>
+          <a:effectRef idx="2">
+            <a:schemeClr val="accent1"/>
+          </a:effectRef>
+          <a:fontRef idx="minor">
+            <a:schemeClr val="lt1"/>
+          </a:fontRef>
+        </p:style>
+        <p:txBody>
+          <a:bodyPr rtlCol="0" anchor="ctr"/>
+          <a:lstStyle/>
+          <a:p>
+            <a:pPr algn="ctr"/>
+          </a:p>
+        </p:txBody>
+      </p:sp>
+      <p:sp>
+        <p:nvSpPr>
+          <p:cNvPr id="29" name="Row 7 date"/>
+          <p:cNvSpPr txBox="1"/>
+          <p:nvPr/>
+        </p:nvSpPr>
+        <p:spPr>
+          <a:xfrm>
+            <a:off x="850490" y="9408535"/>
+            <a:ext cx="1192879" cy="1089050"/>
+          </a:xfrm>
+          <a:prstGeom prst="rect">
+            <a:avLst/>
+          </a:prstGeom>
+          <a:noFill/>
+        </p:spPr>
+        <p:txBody>
+          <a:bodyPr wrap="none" lIns="0" rIns="0" tIns="0" bIns="0" anchor="t">
+            <a:spAutoFit/>
+          </a:bodyPr>
+          <a:lstStyle/>
+          <a:p>
+            <a:pPr algn="l"/>
+            <a:r>
+              <a:rPr sz="5244" b="0" cap="all">
+                <a:solidFill>
+                  <a:srgbClr val="5E1A1D"/>
+                </a:solidFill>
+                <a:latin typeface="Saira Condensed Black"/>
+              </a:rPr>
+              <a:t>10/3</a:t>
+            </a:r>
+          </a:p>
+        </p:txBody>
+      </p:sp>
+      <p:sp>
+        <p:nvSpPr>
+          <p:cNvPr id="30" name="Row 7 opponent"/>
+          <p:cNvSpPr txBox="1"/>
+          <p:nvPr/>
+        </p:nvSpPr>
+        <p:spPr>
+          <a:xfrm>
+            <a:off x="2615915" y="9634037"/>
+            <a:ext cx="4443161" cy="622935"/>
+          </a:xfrm>
+          <a:prstGeom prst="rect">
+            <a:avLst/>
+          </a:prstGeom>
+          <a:noFill/>
+        </p:spPr>
+        <p:txBody>
+          <a:bodyPr wrap="none" lIns="0" rIns="0" tIns="0" bIns="0" anchor="t">
+            <a:spAutoFit/>
+          </a:bodyPr>
+          <a:lstStyle/>
+          <a:p>
+            <a:pPr algn="l"/>
+            <a:r>
+              <a:rPr sz="3000" b="1">
+                <a:solidFill>
+                  <a:srgbClr val="F5EAD5"/>
+                </a:solidFill>
+                <a:latin typeface="Saira"/>
+              </a:rPr>
+              <a:t>vs. Dixie (Homecoming)</a:t>
+            </a:r>
+          </a:p>
+        </p:txBody>
+      </p:sp>
+      <p:sp>
+        <p:nvSpPr>
+          <p:cNvPr id="31" name="Row 7 time"/>
+          <p:cNvSpPr txBox="1"/>
+          <p:nvPr/>
+        </p:nvSpPr>
+        <p:spPr>
+          <a:xfrm>
+            <a:off x="8718691" y="9649106"/>
+            <a:ext cx="882509" cy="591788"/>
+          </a:xfrm>
+          <a:prstGeom prst="rect">
+            <a:avLst/>
+          </a:prstGeom>
+          <a:noFill/>
+        </p:spPr>
+        <p:txBody>
+          <a:bodyPr wrap="none" lIns="0" rIns="0" tIns="0" bIns="0" anchor="t">
+            <a:spAutoFit/>
+          </a:bodyPr>
+          <a:lstStyle/>
+          <a:p>
+            <a:pPr algn="r"/>
+            <a:r>
+              <a:rPr sz="2850" b="1">
+                <a:solidFill>
+                  <a:srgbClr val="F5EAD5"/>
+                </a:solidFill>
+                <a:latin typeface="Saira"/>
+              </a:rPr>
+              <a:t>7:30</a:t>
+            </a:r>
+          </a:p>
+        </p:txBody>
+      </p:sp>
+      <p:sp>
+        <p:nvSpPr>
+          <p:cNvPr id="32" name="Row 8 date panel"/>
+          <p:cNvSpPr/>
+          <p:nvPr/>
+        </p:nvSpPr>
+        <p:spPr>
+          <a:xfrm>
+            <a:off x="685800" y="10732294"/>
+            <a:ext cx="1642234" cy="716042"/>
+          </a:xfrm>
+          <a:custGeom>
+            <a:avLst/>
+            <a:gdLst/>
+            <a:ahLst/>
+            <a:cxnLst/>
+            <a:rect l="l" t="t" r="r" b="b"/>
+            <a:pathLst>
+              <a:path w="1642234" h="716042">
+                <a:moveTo>
+                  <a:pt x="85925" y="0"/>
+                </a:moveTo>
+                <a:lnTo>
+                  <a:pt x="1642234" y="0"/>
+                </a:lnTo>
+                <a:lnTo>
+                  <a:pt x="1556309" y="716042"/>
+                </a:lnTo>
+                <a:lnTo>
+                  <a:pt x="0" y="716042"/>
+                </a:lnTo>
+                <a:lnTo>
+                  <a:pt x="85925" y="0"/>
+                </a:lnTo>
+                <a:close/>
+              </a:path>
+            </a:pathLst>
+          </a:custGeom>
+          <a:solidFill>
+            <a:srgbClr val="F5EAD5"/>
+          </a:solidFill>
+          <a:ln>
+            <a:noFill/>
+          </a:ln>
+        </p:spPr>
+        <p:style>
+          <a:lnRef idx="1">
+            <a:schemeClr val="accent1"/>
+          </a:lnRef>
+          <a:fillRef idx="3">
+            <a:schemeClr val="accent1"/>
+          </a:fillRef>
+          <a:effectRef idx="2">
+            <a:schemeClr val="accent1"/>
+          </a:effectRef>
+          <a:fontRef idx="minor">
+            <a:schemeClr val="lt1"/>
+          </a:fontRef>
+        </p:style>
+        <p:txBody>
+          <a:bodyPr rtlCol="0" anchor="ctr"/>
+          <a:lstStyle/>
+          <a:p>
+            <a:pPr algn="ctr"/>
+          </a:p>
+        </p:txBody>
+      </p:sp>
+      <p:sp>
+        <p:nvSpPr>
+          <p:cNvPr id="33" name="Row 8 date"/>
+          <p:cNvSpPr txBox="1"/>
+          <p:nvPr/>
+        </p:nvSpPr>
+        <p:spPr>
+          <a:xfrm>
+            <a:off x="850490" y="10563441"/>
+            <a:ext cx="1441569" cy="1089050"/>
+          </a:xfrm>
+          <a:prstGeom prst="rect">
+            <a:avLst/>
+          </a:prstGeom>
+          <a:noFill/>
+        </p:spPr>
+        <p:txBody>
+          <a:bodyPr wrap="none" lIns="0" rIns="0" tIns="0" bIns="0" anchor="t">
+            <a:spAutoFit/>
+          </a:bodyPr>
+          <a:lstStyle/>
+          <a:p>
+            <a:pPr algn="l"/>
+            <a:r>
+              <a:rPr sz="5244" b="0" cap="all">
+                <a:solidFill>
+                  <a:srgbClr val="5E1A1D"/>
+                </a:solidFill>
+                <a:latin typeface="Saira Condensed Black"/>
+              </a:rPr>
+              <a:t>10/10</a:t>
+            </a:r>
+          </a:p>
+        </p:txBody>
+      </p:sp>
+      <p:sp>
+        <p:nvSpPr>
+          <p:cNvPr id="34" name="Row 8 opponent"/>
+          <p:cNvSpPr txBox="1"/>
+          <p:nvPr/>
+        </p:nvSpPr>
+        <p:spPr>
+          <a:xfrm>
+            <a:off x="2615915" y="10788944"/>
+            <a:ext cx="5937778" cy="622935"/>
+          </a:xfrm>
+          <a:prstGeom prst="rect">
+            <a:avLst/>
+          </a:prstGeom>
+          <a:noFill/>
+        </p:spPr>
+        <p:txBody>
+          <a:bodyPr wrap="none" lIns="0" rIns="0" tIns="0" bIns="0" anchor="t">
+            <a:spAutoFit/>
+          </a:bodyPr>
+          <a:lstStyle/>
+          <a:p>
+            <a:pPr algn="l"/>
+            <a:r>
+              <a:rPr sz="3000" b="1">
+                <a:solidFill>
+                  <a:srgbClr val="F5EAD5"/>
+                </a:solidFill>
+                <a:latin typeface="Saira"/>
+              </a:rPr>
+              <a:t>at Region tournament, site TBA</a:t>
+            </a:r>
+          </a:p>
+        </p:txBody>
+      </p:sp>
+      <p:sp>
+        <p:nvSpPr>
+          <p:cNvPr id="35" name="Row 8 time"/>
+          <p:cNvSpPr txBox="1"/>
+          <p:nvPr/>
+        </p:nvSpPr>
+        <p:spPr>
+          <a:xfrm>
+            <a:off x="8792095" y="10804012"/>
+            <a:ext cx="809105" cy="591788"/>
+          </a:xfrm>
+          <a:prstGeom prst="rect">
+            <a:avLst/>
+          </a:prstGeom>
+          <a:noFill/>
+        </p:spPr>
+        <p:txBody>
+          <a:bodyPr wrap="none" lIns="0" rIns="0" tIns="0" bIns="0" anchor="t">
+            <a:spAutoFit/>
+          </a:bodyPr>
+          <a:lstStyle/>
+          <a:p>
+            <a:pPr algn="r"/>
+            <a:r>
+              <a:rPr sz="2850" b="1">
+                <a:solidFill>
+                  <a:srgbClr val="F5EAD5"/>
+                </a:solidFill>
+                <a:latin typeface="Saira"/>
+              </a:rPr>
+              <a:t>TBA</a:t>
+            </a:r>
+          </a:p>
+        </p:txBody>
+      </p:sp>
+    </p:spTree>
+  </p:cSld>
+  <p:clrMapOvr>
+    <a:masterClrMapping/>
+  </p:clrMapOvr>
+</p:sld>
+</file>
+
 <file path=ppt/slides/slide2.xml><?xml version="1.0" encoding="utf-8"?>
 <p:sld xmlns:a="http://schemas.openxmlformats.org/drawingml/2006/main" xmlns:p="http://schemas.openxmlformats.org/presentationml/2006/main" xmlns:r="http://schemas.openxmlformats.org/officeDocument/2006/relationships">
   <p:cSld>
@@ -6917,7 +8473,7 @@
       </p:sp>
       <p:pic>
         <p:nvPicPr>
-          <p:cNvPr id="3" name="Team logo" descr="image.png"/>
+          <p:cNvPr id="3" name="Photo (right-click, Change Picture)" descr="image.jpg"/>
           <p:cNvPicPr>
             <a:picLocks noChangeAspect="1"/>
           </p:cNvPicPr>
@@ -6931,8 +8487,32 @@
         </p:blipFill>
         <p:spPr>
           <a:xfrm>
+            <a:off x="0" y="0"/>
+            <a:ext cx="10287000" cy="5143500"/>
+          </a:xfrm>
+          <a:prstGeom prst="rect">
+            <a:avLst/>
+          </a:prstGeom>
+        </p:spPr>
+      </p:pic>
+      <p:pic>
+        <p:nvPicPr>
+          <p:cNvPr id="4" name="Team logo" descr="image.png"/>
+          <p:cNvPicPr>
+            <a:picLocks noChangeAspect="1"/>
+          </p:cNvPicPr>
+          <p:nvPr/>
+        </p:nvPicPr>
+        <p:blipFill>
+          <a:blip r:embed="rId3"/>
+          <a:stretch>
+            <a:fillRect/>
+          </a:stretch>
+        </p:blipFill>
+        <p:spPr>
+          <a:xfrm>
             <a:off x="685800" y="11658600"/>
-            <a:ext cx="4143772" cy="514350"/>
+            <a:ext cx="2720030" cy="514350"/>
           </a:xfrm>
           <a:prstGeom prst="rect">
             <a:avLst/>
@@ -6941,13 +8521,13 @@
       </p:pic>
       <p:sp>
         <p:nvSpPr>
-          <p:cNvPr id="4" name="Tag panel"/>
+          <p:cNvPr id="5" name="Tag panel"/>
           <p:cNvSpPr/>
           <p:nvPr/>
         </p:nvSpPr>
         <p:spPr>
           <a:xfrm>
-            <a:off x="685800" y="2987064"/>
+            <a:off x="685800" y="5676900"/>
             <a:ext cx="2022710" cy="495300"/>
           </a:xfrm>
           <a:custGeom>
@@ -7008,13 +8588,13 @@
       </p:sp>
       <p:sp>
         <p:nvSpPr>
-          <p:cNvPr id="5" name="Tag"/>
+          <p:cNvPr id="6" name="Tag"/>
           <p:cNvSpPr txBox="1"/>
           <p:nvPr/>
         </p:nvSpPr>
         <p:spPr>
           <a:xfrm>
-            <a:off x="888873" y="2949988"/>
+            <a:off x="888873" y="5639824"/>
             <a:ext cx="1757427" cy="588529"/>
           </a:xfrm>
           <a:prstGeom prst="rect">
@@ -7043,14 +8623,14 @@
       </p:sp>
       <p:sp>
         <p:nvSpPr>
-          <p:cNvPr id="6" name="Wildcats score panel"/>
+          <p:cNvPr id="7" name="Wildcats score panel"/>
           <p:cNvSpPr/>
           <p:nvPr/>
         </p:nvSpPr>
         <p:spPr>
           <a:xfrm>
-            <a:off x="685800" y="3958614"/>
-            <a:ext cx="4030412" cy="2693622"/>
+            <a:off x="685800" y="6648450"/>
+            <a:ext cx="2025228" cy="2305050"/>
           </a:xfrm>
           <a:custGeom>
             <a:avLst/>
@@ -7059,21 +8639,21 @@
             <a:cxnLst/>
             <a:rect l="l" t="t" r="r" b="b"/>
             <a:pathLst>
-              <a:path w="4030412" h="2693622">
+              <a:path w="2025228" h="2305050">
                 <a:moveTo>
-                  <a:pt x="323235" y="0"/>
+                  <a:pt x="276606" y="0"/>
                 </a:moveTo>
                 <a:lnTo>
-                  <a:pt x="4030412" y="0"/>
-                </a:lnTo>
-                <a:lnTo>
-                  <a:pt x="3707177" y="2693622"/>
-                </a:lnTo>
-                <a:lnTo>
-                  <a:pt x="0" y="2693622"/>
-                </a:lnTo>
-                <a:lnTo>
-                  <a:pt x="323235" y="0"/>
+                  <a:pt x="2025228" y="0"/>
+                </a:lnTo>
+                <a:lnTo>
+                  <a:pt x="1748622" y="2305050"/>
+                </a:lnTo>
+                <a:lnTo>
+                  <a:pt x="0" y="2305050"/>
+                </a:lnTo>
+                <a:lnTo>
+                  <a:pt x="276606" y="0"/>
                 </a:lnTo>
                 <a:close/>
               </a:path>
@@ -7110,14 +8690,14 @@
       </p:sp>
       <p:sp>
         <p:nvSpPr>
-          <p:cNvPr id="7" name="Wildcats score"/>
+          <p:cNvPr id="8" name="Wildcats score"/>
           <p:cNvSpPr txBox="1"/>
           <p:nvPr/>
         </p:nvSpPr>
         <p:spPr>
           <a:xfrm>
-            <a:off x="1305333" y="3323420"/>
-            <a:ext cx="2979199" cy="4096813"/>
+            <a:off x="1215962" y="6104887"/>
+            <a:ext cx="1079701" cy="3505820"/>
           </a:xfrm>
           <a:prstGeom prst="rect">
             <a:avLst/>
@@ -7132,27 +8712,27 @@
           <a:p>
             <a:pPr algn="l"/>
             <a:r>
-              <a:rPr sz="19729" b="0" cap="all">
+              <a:rPr sz="16883" b="0" cap="all">
                 <a:solidFill>
                   <a:srgbClr val="5E1A1D"/>
                 </a:solidFill>
                 <a:latin typeface="Saira Condensed Black"/>
               </a:rPr>
-              <a:t>112</a:t>
-            </a:r>
-          </a:p>
-        </p:txBody>
-      </p:sp>
-      <p:sp>
-        <p:nvSpPr>
-          <p:cNvPr id="8" name="Opponent score panel"/>
+              <a:t>3</a:t>
+            </a:r>
+          </a:p>
+        </p:txBody>
+      </p:sp>
+      <p:sp>
+        <p:nvSpPr>
+          <p:cNvPr id="9" name="Opponent score panel"/>
           <p:cNvSpPr/>
           <p:nvPr/>
         </p:nvSpPr>
         <p:spPr>
           <a:xfrm>
-            <a:off x="5097212" y="3958614"/>
-            <a:ext cx="4503988" cy="2693622"/>
+            <a:off x="3092028" y="6648450"/>
+            <a:ext cx="1759342" cy="2305050"/>
           </a:xfrm>
           <a:custGeom>
             <a:avLst/>
@@ -7161,21 +8741,21 @@
             <a:cxnLst/>
             <a:rect l="l" t="t" r="r" b="b"/>
             <a:pathLst>
-              <a:path w="4503988" h="2693622">
+              <a:path w="1759342" h="2305050">
                 <a:moveTo>
-                  <a:pt x="323234" y="0"/>
+                  <a:pt x="276606" y="0"/>
                 </a:moveTo>
                 <a:lnTo>
-                  <a:pt x="4503988" y="0"/>
-                </a:lnTo>
-                <a:lnTo>
-                  <a:pt x="4180753" y="2693622"/>
-                </a:lnTo>
-                <a:lnTo>
-                  <a:pt x="0" y="2693622"/>
-                </a:lnTo>
-                <a:lnTo>
-                  <a:pt x="323234" y="0"/>
+                  <a:pt x="1759342" y="0"/>
+                </a:lnTo>
+                <a:lnTo>
+                  <a:pt x="1482736" y="2305050"/>
+                </a:lnTo>
+                <a:lnTo>
+                  <a:pt x="0" y="2305050"/>
+                </a:lnTo>
+                <a:lnTo>
+                  <a:pt x="276606" y="0"/>
                 </a:lnTo>
                 <a:close/>
               </a:path>
@@ -7212,14 +8792,14 @@
       </p:sp>
       <p:sp>
         <p:nvSpPr>
-          <p:cNvPr id="9" name="Opponent score"/>
+          <p:cNvPr id="10" name="Opponent score"/>
           <p:cNvSpPr txBox="1"/>
           <p:nvPr/>
         </p:nvSpPr>
         <p:spPr>
           <a:xfrm>
-            <a:off x="5716745" y="3323420"/>
-            <a:ext cx="3471719" cy="4096813"/>
+            <a:off x="3622189" y="6104887"/>
+            <a:ext cx="803181" cy="3505820"/>
           </a:xfrm>
           <a:prstGeom prst="rect">
             <a:avLst/>
@@ -7234,26 +8814,26 @@
           <a:p>
             <a:pPr algn="l"/>
             <a:r>
-              <a:rPr sz="19729" b="0" cap="all">
+              <a:rPr sz="16883" b="0" cap="all">
                 <a:solidFill>
                   <a:srgbClr val="F5EAD5"/>
                 </a:solidFill>
                 <a:latin typeface="Saira Condensed Black"/>
               </a:rPr>
-              <a:t>108</a:t>
-            </a:r>
-          </a:p>
-        </p:txBody>
-      </p:sp>
-      <p:sp>
-        <p:nvSpPr>
-          <p:cNvPr id="10" name="Wildcats label"/>
+              <a:t>1</a:t>
+            </a:r>
+          </a:p>
+        </p:txBody>
+      </p:sp>
+      <p:sp>
+        <p:nvSpPr>
+          <p:cNvPr id="11" name="Wildcats label"/>
           <p:cNvSpPr txBox="1"/>
           <p:nvPr/>
         </p:nvSpPr>
         <p:spPr>
           <a:xfrm>
-            <a:off x="685800" y="6886552"/>
+            <a:off x="685800" y="9187815"/>
             <a:ext cx="2032437" cy="622935"/>
           </a:xfrm>
           <a:prstGeom prst="rect">
@@ -7282,14 +8862,14 @@
       </p:sp>
       <p:sp>
         <p:nvSpPr>
-          <p:cNvPr id="11" name="Opponent label"/>
+          <p:cNvPr id="12" name="Opponent label"/>
           <p:cNvSpPr txBox="1"/>
           <p:nvPr/>
         </p:nvSpPr>
         <p:spPr>
           <a:xfrm>
-            <a:off x="5097212" y="6886552"/>
-            <a:ext cx="2100194" cy="622935"/>
+            <a:off x="3092028" y="9187815"/>
+            <a:ext cx="1348130" cy="622935"/>
           </a:xfrm>
           <a:prstGeom prst="rect">
             <a:avLst/>
@@ -7310,21 +8890,21 @@
                 </a:solidFill>
                 <a:latin typeface="Saira"/>
               </a:rPr>
-              <a:t>McCormick</a:t>
-            </a:r>
-          </a:p>
-        </p:txBody>
-      </p:sp>
-      <p:sp>
-        <p:nvSpPr>
-          <p:cNvPr id="12" name="Note"/>
+              <a:t>Saluda</a:t>
+            </a:r>
+          </a:p>
+        </p:txBody>
+      </p:sp>
+      <p:sp>
+        <p:nvSpPr>
+          <p:cNvPr id="13" name="Note"/>
           <p:cNvSpPr txBox="1"/>
           <p:nvPr/>
         </p:nvSpPr>
         <p:spPr>
           <a:xfrm>
-            <a:off x="685800" y="7710845"/>
-            <a:ext cx="1719130" cy="560642"/>
+            <a:off x="685800" y="10012109"/>
+            <a:ext cx="2047217" cy="560642"/>
           </a:xfrm>
           <a:prstGeom prst="rect">
             <a:avLst/>
@@ -7345,7 +8925,7 @@
                 </a:solidFill>
                 <a:latin typeface="Saira"/>
               </a:rPr>
-              <a:t>Final, 2OT</a:t>
+              <a:t>Region 1-2A</a:t>
             </a:r>
           </a:p>
         </p:txBody>
@@ -7451,8 +9031,8 @@
         </p:blipFill>
         <p:spPr>
           <a:xfrm>
-            <a:off x="685800" y="685800"/>
-            <a:ext cx="4785200" cy="723900"/>
+            <a:off x="685800" y="11658600"/>
+            <a:ext cx="4143772" cy="514350"/>
           </a:xfrm>
           <a:prstGeom prst="rect">
             <a:avLst/>
@@ -7461,49 +9041,14 @@
       </p:pic>
       <p:sp>
         <p:nvSpPr>
-          <p:cNvPr id="4" name="Title"/>
-          <p:cNvSpPr txBox="1"/>
-          <p:nvPr/>
-        </p:nvSpPr>
-        <p:spPr>
-          <a:xfrm>
-            <a:off x="685800" y="1708880"/>
-            <a:ext cx="3284258" cy="529495"/>
-          </a:xfrm>
-          <a:prstGeom prst="rect">
-            <a:avLst/>
-          </a:prstGeom>
-          <a:noFill/>
-        </p:spPr>
-        <p:txBody>
-          <a:bodyPr wrap="none" lIns="0" rIns="0" tIns="0" bIns="0" anchor="t">
-            <a:spAutoFit/>
-          </a:bodyPr>
-          <a:lstStyle/>
-          <a:p>
-            <a:pPr algn="l"/>
-            <a:r>
-              <a:rPr sz="2550" b="1" spc="357" cap="all">
-                <a:solidFill>
-                  <a:srgbClr val="F5EAD5"/>
-                </a:solidFill>
-                <a:latin typeface="Saira"/>
-              </a:rPr>
-              <a:t>2026 SCHEDULE</a:t>
-            </a:r>
-          </a:p>
-        </p:txBody>
-      </p:sp>
-      <p:sp>
-        <p:nvSpPr>
-          <p:cNvPr id="5" name="Row 1 date panel"/>
+          <p:cNvPr id="4" name="Tag panel"/>
           <p:cNvSpPr/>
           <p:nvPr/>
         </p:nvSpPr>
         <p:spPr>
           <a:xfrm>
-            <a:off x="685800" y="2647950"/>
-            <a:ext cx="1509017" cy="716042"/>
+            <a:off x="685800" y="2987064"/>
+            <a:ext cx="2022710" cy="495300"/>
           </a:xfrm>
           <a:custGeom>
             <a:avLst/>
@@ -7512,21 +9057,21 @@
             <a:cxnLst/>
             <a:rect l="l" t="t" r="r" b="b"/>
             <a:pathLst>
-              <a:path w="1509017" h="716042">
+              <a:path w="2022710" h="495300">
                 <a:moveTo>
-                  <a:pt x="85925" y="0"/>
+                  <a:pt x="59436" y="0"/>
                 </a:moveTo>
                 <a:lnTo>
-                  <a:pt x="1509017" y="0"/>
-                </a:lnTo>
-                <a:lnTo>
-                  <a:pt x="1423092" y="716042"/>
-                </a:lnTo>
-                <a:lnTo>
-                  <a:pt x="0" y="716042"/>
-                </a:lnTo>
-                <a:lnTo>
-                  <a:pt x="85925" y="0"/>
+                  <a:pt x="2022710" y="0"/>
+                </a:lnTo>
+                <a:lnTo>
+                  <a:pt x="1963274" y="495300"/>
+                </a:lnTo>
+                <a:lnTo>
+                  <a:pt x="0" y="495300"/>
+                </a:lnTo>
+                <a:lnTo>
+                  <a:pt x="59436" y="0"/>
                 </a:lnTo>
                 <a:close/>
               </a:path>
@@ -7563,14 +9108,14 @@
       </p:sp>
       <p:sp>
         <p:nvSpPr>
-          <p:cNvPr id="6" name="Row 1 date"/>
+          <p:cNvPr id="5" name="Tag"/>
           <p:cNvSpPr txBox="1"/>
           <p:nvPr/>
         </p:nvSpPr>
         <p:spPr>
           <a:xfrm>
-            <a:off x="850490" y="2479097"/>
-            <a:ext cx="1303023" cy="1089050"/>
+            <a:off x="888873" y="2949988"/>
+            <a:ext cx="1757427" cy="588529"/>
           </a:xfrm>
           <a:prstGeom prst="rect">
             <a:avLst/>
@@ -7585,97 +9130,27 @@
           <a:p>
             <a:pPr algn="l"/>
             <a:r>
-              <a:rPr sz="5244" b="0" cap="all">
+              <a:rPr sz="2834" b="0" spc="56" cap="all">
                 <a:solidFill>
                   <a:srgbClr val="5E1A1D"/>
                 </a:solidFill>
                 <a:latin typeface="Saira Condensed Black"/>
               </a:rPr>
-              <a:t>8/22</a:t>
-            </a:r>
-          </a:p>
-        </p:txBody>
-      </p:sp>
-      <p:sp>
-        <p:nvSpPr>
-          <p:cNvPr id="7" name="Row 1 opponent"/>
-          <p:cNvSpPr txBox="1"/>
-          <p:nvPr/>
-        </p:nvSpPr>
-        <p:spPr>
-          <a:xfrm>
-            <a:off x="2615915" y="2704600"/>
-            <a:ext cx="2447300" cy="622935"/>
-          </a:xfrm>
-          <a:prstGeom prst="rect">
-            <a:avLst/>
-          </a:prstGeom>
-          <a:noFill/>
-        </p:spPr>
-        <p:txBody>
-          <a:bodyPr wrap="none" lIns="0" rIns="0" tIns="0" bIns="0" anchor="t">
-            <a:spAutoFit/>
-          </a:bodyPr>
-          <a:lstStyle/>
-          <a:p>
-            <a:pPr algn="l"/>
-            <a:r>
-              <a:rPr sz="3000" b="1">
-                <a:solidFill>
-                  <a:srgbClr val="F5EAD5"/>
-                </a:solidFill>
-                <a:latin typeface="Saira"/>
-              </a:rPr>
-              <a:t>vs. Abbeville</a:t>
-            </a:r>
-          </a:p>
-        </p:txBody>
-      </p:sp>
-      <p:sp>
-        <p:nvSpPr>
-          <p:cNvPr id="8" name="Row 1 time"/>
-          <p:cNvSpPr txBox="1"/>
-          <p:nvPr/>
-        </p:nvSpPr>
-        <p:spPr>
-          <a:xfrm>
-            <a:off x="8718691" y="2719668"/>
-            <a:ext cx="882509" cy="591788"/>
-          </a:xfrm>
-          <a:prstGeom prst="rect">
-            <a:avLst/>
-          </a:prstGeom>
-          <a:noFill/>
-        </p:spPr>
-        <p:txBody>
-          <a:bodyPr wrap="none" lIns="0" rIns="0" tIns="0" bIns="0" anchor="t">
-            <a:spAutoFit/>
-          </a:bodyPr>
-          <a:lstStyle/>
-          <a:p>
-            <a:pPr algn="r"/>
-            <a:r>
-              <a:rPr sz="2850" b="1">
-                <a:solidFill>
-                  <a:srgbClr val="F5EAD5"/>
-                </a:solidFill>
-                <a:latin typeface="Saira"/>
-              </a:rPr>
-              <a:t>7:30</a:t>
-            </a:r>
-          </a:p>
-        </p:txBody>
-      </p:sp>
-      <p:sp>
-        <p:nvSpPr>
-          <p:cNvPr id="9" name="Row 2 date panel"/>
+              <a:t>FINAL · WIN</a:t>
+            </a:r>
+          </a:p>
+        </p:txBody>
+      </p:sp>
+      <p:sp>
+        <p:nvSpPr>
+          <p:cNvPr id="6" name="Wildcats score panel"/>
           <p:cNvSpPr/>
           <p:nvPr/>
         </p:nvSpPr>
         <p:spPr>
           <a:xfrm>
-            <a:off x="685800" y="3802856"/>
-            <a:ext cx="1521672" cy="716042"/>
+            <a:off x="685800" y="3958614"/>
+            <a:ext cx="4030412" cy="2693622"/>
           </a:xfrm>
           <a:custGeom>
             <a:avLst/>
@@ -7684,21 +9159,21 @@
             <a:cxnLst/>
             <a:rect l="l" t="t" r="r" b="b"/>
             <a:pathLst>
-              <a:path w="1521672" h="716042">
+              <a:path w="4030412" h="2693622">
                 <a:moveTo>
-                  <a:pt x="85925" y="0"/>
+                  <a:pt x="323235" y="0"/>
                 </a:moveTo>
                 <a:lnTo>
-                  <a:pt x="1521672" y="0"/>
-                </a:lnTo>
-                <a:lnTo>
-                  <a:pt x="1435747" y="716042"/>
-                </a:lnTo>
-                <a:lnTo>
-                  <a:pt x="0" y="716042"/>
-                </a:lnTo>
-                <a:lnTo>
-                  <a:pt x="85925" y="0"/>
+                  <a:pt x="4030412" y="0"/>
+                </a:lnTo>
+                <a:lnTo>
+                  <a:pt x="3707177" y="2693622"/>
+                </a:lnTo>
+                <a:lnTo>
+                  <a:pt x="0" y="2693622"/>
+                </a:lnTo>
+                <a:lnTo>
+                  <a:pt x="323235" y="0"/>
                 </a:lnTo>
                 <a:close/>
               </a:path>
@@ -7735,14 +9210,14 @@
       </p:sp>
       <p:sp>
         <p:nvSpPr>
-          <p:cNvPr id="10" name="Row 2 date"/>
+          <p:cNvPr id="7" name="Wildcats score"/>
           <p:cNvSpPr txBox="1"/>
           <p:nvPr/>
         </p:nvSpPr>
         <p:spPr>
           <a:xfrm>
-            <a:off x="850490" y="3634004"/>
-            <a:ext cx="1316185" cy="1089050"/>
+            <a:off x="1305333" y="3323420"/>
+            <a:ext cx="2979199" cy="4096813"/>
           </a:xfrm>
           <a:prstGeom prst="rect">
             <a:avLst/>
@@ -7757,27 +9232,129 @@
           <a:p>
             <a:pPr algn="l"/>
             <a:r>
-              <a:rPr sz="5244" b="0" cap="all">
+              <a:rPr sz="19729" b="0" cap="all">
                 <a:solidFill>
                   <a:srgbClr val="5E1A1D"/>
                 </a:solidFill>
                 <a:latin typeface="Saira Condensed Black"/>
               </a:rPr>
-              <a:t>8/29</a:t>
-            </a:r>
-          </a:p>
-        </p:txBody>
-      </p:sp>
-      <p:sp>
-        <p:nvSpPr>
-          <p:cNvPr id="11" name="Row 2 opponent"/>
+              <a:t>112</a:t>
+            </a:r>
+          </a:p>
+        </p:txBody>
+      </p:sp>
+      <p:sp>
+        <p:nvSpPr>
+          <p:cNvPr id="8" name="Opponent score panel"/>
+          <p:cNvSpPr/>
+          <p:nvPr/>
+        </p:nvSpPr>
+        <p:spPr>
+          <a:xfrm>
+            <a:off x="5097212" y="3958614"/>
+            <a:ext cx="4503988" cy="2693622"/>
+          </a:xfrm>
+          <a:custGeom>
+            <a:avLst/>
+            <a:gdLst/>
+            <a:ahLst/>
+            <a:cxnLst/>
+            <a:rect l="l" t="t" r="r" b="b"/>
+            <a:pathLst>
+              <a:path w="4503988" h="2693622">
+                <a:moveTo>
+                  <a:pt x="323234" y="0"/>
+                </a:moveTo>
+                <a:lnTo>
+                  <a:pt x="4503988" y="0"/>
+                </a:lnTo>
+                <a:lnTo>
+                  <a:pt x="4180753" y="2693622"/>
+                </a:lnTo>
+                <a:lnTo>
+                  <a:pt x="0" y="2693622"/>
+                </a:lnTo>
+                <a:lnTo>
+                  <a:pt x="323234" y="0"/>
+                </a:lnTo>
+                <a:close/>
+              </a:path>
+            </a:pathLst>
+          </a:custGeom>
+          <a:solidFill>
+            <a:srgbClr val="000000"/>
+          </a:solidFill>
+          <a:ln>
+            <a:noFill/>
+          </a:ln>
+        </p:spPr>
+        <p:style>
+          <a:lnRef idx="1">
+            <a:schemeClr val="accent1"/>
+          </a:lnRef>
+          <a:fillRef idx="3">
+            <a:schemeClr val="accent1"/>
+          </a:fillRef>
+          <a:effectRef idx="2">
+            <a:schemeClr val="accent1"/>
+          </a:effectRef>
+          <a:fontRef idx="minor">
+            <a:schemeClr val="lt1"/>
+          </a:fontRef>
+        </p:style>
+        <p:txBody>
+          <a:bodyPr rtlCol="0" anchor="ctr"/>
+          <a:lstStyle/>
+          <a:p>
+            <a:pPr algn="ctr"/>
+          </a:p>
+        </p:txBody>
+      </p:sp>
+      <p:sp>
+        <p:nvSpPr>
+          <p:cNvPr id="9" name="Opponent score"/>
           <p:cNvSpPr txBox="1"/>
           <p:nvPr/>
         </p:nvSpPr>
         <p:spPr>
           <a:xfrm>
-            <a:off x="2615915" y="3859506"/>
-            <a:ext cx="6111728" cy="622935"/>
+            <a:off x="5716745" y="3323420"/>
+            <a:ext cx="3471719" cy="4096813"/>
+          </a:xfrm>
+          <a:prstGeom prst="rect">
+            <a:avLst/>
+          </a:prstGeom>
+          <a:noFill/>
+        </p:spPr>
+        <p:txBody>
+          <a:bodyPr wrap="none" lIns="0" rIns="0" tIns="0" bIns="0" anchor="t">
+            <a:spAutoFit/>
+          </a:bodyPr>
+          <a:lstStyle/>
+          <a:p>
+            <a:pPr algn="l"/>
+            <a:r>
+              <a:rPr sz="19729" b="0" cap="all">
+                <a:solidFill>
+                  <a:srgbClr val="F5EAD5"/>
+                </a:solidFill>
+                <a:latin typeface="Saira Condensed Black"/>
+              </a:rPr>
+              <a:t>108</a:t>
+            </a:r>
+          </a:p>
+        </p:txBody>
+      </p:sp>
+      <p:sp>
+        <p:nvSpPr>
+          <p:cNvPr id="10" name="Wildcats label"/>
+          <p:cNvSpPr txBox="1"/>
+          <p:nvPr/>
+        </p:nvSpPr>
+        <p:spPr>
+          <a:xfrm>
+            <a:off x="685800" y="6886552"/>
+            <a:ext cx="2032437" cy="622935"/>
           </a:xfrm>
           <a:prstGeom prst="rect">
             <a:avLst/>
@@ -7798,674 +9375,21 @@
                 </a:solidFill>
                 <a:latin typeface="Saira"/>
               </a:rPr>
-              <a:t>at Westwood Christian Academy</a:t>
-            </a:r>
-          </a:p>
-        </p:txBody>
-      </p:sp>
-      <p:sp>
-        <p:nvSpPr>
-          <p:cNvPr id="12" name="Row 2 time"/>
+              <a:t>WILDCATS</a:t>
+            </a:r>
+          </a:p>
+        </p:txBody>
+      </p:sp>
+      <p:sp>
+        <p:nvSpPr>
+          <p:cNvPr id="11" name="Opponent label"/>
           <p:cNvSpPr txBox="1"/>
           <p:nvPr/>
         </p:nvSpPr>
         <p:spPr>
           <a:xfrm>
-            <a:off x="8697988" y="3874575"/>
-            <a:ext cx="903212" cy="591788"/>
-          </a:xfrm>
-          <a:prstGeom prst="rect">
-            <a:avLst/>
-          </a:prstGeom>
-          <a:noFill/>
-        </p:spPr>
-        <p:txBody>
-          <a:bodyPr wrap="none" lIns="0" rIns="0" tIns="0" bIns="0" anchor="t">
-            <a:spAutoFit/>
-          </a:bodyPr>
-          <a:lstStyle/>
-          <a:p>
-            <a:pPr algn="r"/>
-            <a:r>
-              <a:rPr sz="2850" b="1">
-                <a:solidFill>
-                  <a:srgbClr val="F5EAD5"/>
-                </a:solidFill>
-                <a:latin typeface="Saira"/>
-              </a:rPr>
-              <a:t>7:00</a:t>
-            </a:r>
-          </a:p>
-        </p:txBody>
-      </p:sp>
-      <p:sp>
-        <p:nvSpPr>
-          <p:cNvPr id="13" name="Row 3 date panel"/>
-          <p:cNvSpPr/>
-          <p:nvPr/>
-        </p:nvSpPr>
-        <p:spPr>
-          <a:xfrm>
-            <a:off x="685800" y="4957762"/>
-            <a:ext cx="1195957" cy="716042"/>
-          </a:xfrm>
-          <a:custGeom>
-            <a:avLst/>
-            <a:gdLst/>
-            <a:ahLst/>
-            <a:cxnLst/>
-            <a:rect l="l" t="t" r="r" b="b"/>
-            <a:pathLst>
-              <a:path w="1195957" h="716042">
-                <a:moveTo>
-                  <a:pt x="85925" y="0"/>
-                </a:moveTo>
-                <a:lnTo>
-                  <a:pt x="1195957" y="0"/>
-                </a:lnTo>
-                <a:lnTo>
-                  <a:pt x="1110031" y="716042"/>
-                </a:lnTo>
-                <a:lnTo>
-                  <a:pt x="0" y="716042"/>
-                </a:lnTo>
-                <a:lnTo>
-                  <a:pt x="85925" y="0"/>
-                </a:lnTo>
-                <a:close/>
-              </a:path>
-            </a:pathLst>
-          </a:custGeom>
-          <a:solidFill>
-            <a:srgbClr val="F5EAD5"/>
-          </a:solidFill>
-          <a:ln>
-            <a:noFill/>
-          </a:ln>
-        </p:spPr>
-        <p:style>
-          <a:lnRef idx="1">
-            <a:schemeClr val="accent1"/>
-          </a:lnRef>
-          <a:fillRef idx="3">
-            <a:schemeClr val="accent1"/>
-          </a:fillRef>
-          <a:effectRef idx="2">
-            <a:schemeClr val="accent1"/>
-          </a:effectRef>
-          <a:fontRef idx="minor">
-            <a:schemeClr val="lt1"/>
-          </a:fontRef>
-        </p:style>
-        <p:txBody>
-          <a:bodyPr rtlCol="0" anchor="ctr"/>
-          <a:lstStyle/>
-          <a:p>
-            <a:pPr algn="ctr"/>
-          </a:p>
-        </p:txBody>
-      </p:sp>
-      <p:sp>
-        <p:nvSpPr>
-          <p:cNvPr id="14" name="Row 3 date"/>
-          <p:cNvSpPr txBox="1"/>
-          <p:nvPr/>
-        </p:nvSpPr>
-        <p:spPr>
-          <a:xfrm>
-            <a:off x="850490" y="4788910"/>
-            <a:ext cx="977440" cy="1089050"/>
-          </a:xfrm>
-          <a:prstGeom prst="rect">
-            <a:avLst/>
-          </a:prstGeom>
-          <a:noFill/>
-        </p:spPr>
-        <p:txBody>
-          <a:bodyPr wrap="none" lIns="0" rIns="0" tIns="0" bIns="0" anchor="t">
-            <a:spAutoFit/>
-          </a:bodyPr>
-          <a:lstStyle/>
-          <a:p>
-            <a:pPr algn="l"/>
-            <a:r>
-              <a:rPr sz="5244" b="0" cap="all">
-                <a:solidFill>
-                  <a:srgbClr val="5E1A1D"/>
-                </a:solidFill>
-                <a:latin typeface="Saira Condensed Black"/>
-              </a:rPr>
-              <a:t>9/5</a:t>
-            </a:r>
-          </a:p>
-        </p:txBody>
-      </p:sp>
-      <p:sp>
-        <p:nvSpPr>
-          <p:cNvPr id="15" name="Row 3 opponent"/>
-          <p:cNvSpPr txBox="1"/>
-          <p:nvPr/>
-        </p:nvSpPr>
-        <p:spPr>
-          <a:xfrm>
-            <a:off x="2615915" y="5014412"/>
-            <a:ext cx="1982907" cy="622935"/>
-          </a:xfrm>
-          <a:prstGeom prst="rect">
-            <a:avLst/>
-          </a:prstGeom>
-          <a:noFill/>
-        </p:spPr>
-        <p:txBody>
-          <a:bodyPr wrap="none" lIns="0" rIns="0" tIns="0" bIns="0" anchor="t">
-            <a:spAutoFit/>
-          </a:bodyPr>
-          <a:lstStyle/>
-          <a:p>
-            <a:pPr algn="l"/>
-            <a:r>
-              <a:rPr sz="3000" b="1">
-                <a:solidFill>
-                  <a:srgbClr val="F5EAD5"/>
-                </a:solidFill>
-                <a:latin typeface="Saira"/>
-              </a:rPr>
-              <a:t>vs. Saluda</a:t>
-            </a:r>
-          </a:p>
-        </p:txBody>
-      </p:sp>
-      <p:sp>
-        <p:nvSpPr>
-          <p:cNvPr id="16" name="Row 3 time"/>
-          <p:cNvSpPr txBox="1"/>
-          <p:nvPr/>
-        </p:nvSpPr>
-        <p:spPr>
-          <a:xfrm>
-            <a:off x="8718691" y="5029481"/>
-            <a:ext cx="882509" cy="591788"/>
-          </a:xfrm>
-          <a:prstGeom prst="rect">
-            <a:avLst/>
-          </a:prstGeom>
-          <a:noFill/>
-        </p:spPr>
-        <p:txBody>
-          <a:bodyPr wrap="none" lIns="0" rIns="0" tIns="0" bIns="0" anchor="t">
-            <a:spAutoFit/>
-          </a:bodyPr>
-          <a:lstStyle/>
-          <a:p>
-            <a:pPr algn="r"/>
-            <a:r>
-              <a:rPr sz="2850" b="1">
-                <a:solidFill>
-                  <a:srgbClr val="F5EAD5"/>
-                </a:solidFill>
-                <a:latin typeface="Saira"/>
-              </a:rPr>
-              <a:t>7:30</a:t>
-            </a:r>
-          </a:p>
-        </p:txBody>
-      </p:sp>
-      <p:sp>
-        <p:nvSpPr>
-          <p:cNvPr id="17" name="Row 4 date panel"/>
-          <p:cNvSpPr/>
-          <p:nvPr/>
-        </p:nvSpPr>
-        <p:spPr>
-          <a:xfrm>
-            <a:off x="685800" y="6112669"/>
-            <a:ext cx="1409770" cy="716042"/>
-          </a:xfrm>
-          <a:custGeom>
-            <a:avLst/>
-            <a:gdLst/>
-            <a:ahLst/>
-            <a:cxnLst/>
-            <a:rect l="l" t="t" r="r" b="b"/>
-            <a:pathLst>
-              <a:path w="1409770" h="716042">
-                <a:moveTo>
-                  <a:pt x="85925" y="0"/>
-                </a:moveTo>
-                <a:lnTo>
-                  <a:pt x="1409770" y="0"/>
-                </a:lnTo>
-                <a:lnTo>
-                  <a:pt x="1323845" y="716042"/>
-                </a:lnTo>
-                <a:lnTo>
-                  <a:pt x="0" y="716042"/>
-                </a:lnTo>
-                <a:lnTo>
-                  <a:pt x="85925" y="0"/>
-                </a:lnTo>
-                <a:close/>
-              </a:path>
-            </a:pathLst>
-          </a:custGeom>
-          <a:solidFill>
-            <a:srgbClr val="F5EAD5"/>
-          </a:solidFill>
-          <a:ln>
-            <a:noFill/>
-          </a:ln>
-        </p:spPr>
-        <p:style>
-          <a:lnRef idx="1">
-            <a:schemeClr val="accent1"/>
-          </a:lnRef>
-          <a:fillRef idx="3">
-            <a:schemeClr val="accent1"/>
-          </a:fillRef>
-          <a:effectRef idx="2">
-            <a:schemeClr val="accent1"/>
-          </a:effectRef>
-          <a:fontRef idx="minor">
-            <a:schemeClr val="lt1"/>
-          </a:fontRef>
-        </p:style>
-        <p:txBody>
-          <a:bodyPr rtlCol="0" anchor="ctr"/>
-          <a:lstStyle/>
-          <a:p>
-            <a:pPr algn="ctr"/>
-          </a:p>
-        </p:txBody>
-      </p:sp>
-      <p:sp>
-        <p:nvSpPr>
-          <p:cNvPr id="18" name="Row 4 date"/>
-          <p:cNvSpPr txBox="1"/>
-          <p:nvPr/>
-        </p:nvSpPr>
-        <p:spPr>
-          <a:xfrm>
-            <a:off x="850490" y="5943816"/>
-            <a:ext cx="1199806" cy="1089050"/>
-          </a:xfrm>
-          <a:prstGeom prst="rect">
-            <a:avLst/>
-          </a:prstGeom>
-          <a:noFill/>
-        </p:spPr>
-        <p:txBody>
-          <a:bodyPr wrap="none" lIns="0" rIns="0" tIns="0" bIns="0" anchor="t">
-            <a:spAutoFit/>
-          </a:bodyPr>
-          <a:lstStyle/>
-          <a:p>
-            <a:pPr algn="l"/>
-            <a:r>
-              <a:rPr sz="5244" b="0" cap="all">
-                <a:solidFill>
-                  <a:srgbClr val="5E1A1D"/>
-                </a:solidFill>
-                <a:latin typeface="Saira Condensed Black"/>
-              </a:rPr>
-              <a:t>9/12</a:t>
-            </a:r>
-          </a:p>
-        </p:txBody>
-      </p:sp>
-      <p:sp>
-        <p:nvSpPr>
-          <p:cNvPr id="19" name="Row 4 opponent"/>
-          <p:cNvSpPr txBox="1"/>
-          <p:nvPr/>
-        </p:nvSpPr>
-        <p:spPr>
-          <a:xfrm>
-            <a:off x="2615915" y="6169319"/>
-            <a:ext cx="2584003" cy="622935"/>
-          </a:xfrm>
-          <a:prstGeom prst="rect">
-            <a:avLst/>
-          </a:prstGeom>
-          <a:noFill/>
-        </p:spPr>
-        <p:txBody>
-          <a:bodyPr wrap="none" lIns="0" rIns="0" tIns="0" bIns="0" anchor="t">
-            <a:spAutoFit/>
-          </a:bodyPr>
-          <a:lstStyle/>
-          <a:p>
-            <a:pPr algn="l"/>
-            <a:r>
-              <a:rPr sz="3000" b="1">
-                <a:solidFill>
-                  <a:srgbClr val="F5EAD5"/>
-                </a:solidFill>
-                <a:latin typeface="Saira"/>
-              </a:rPr>
-              <a:t>at McCormick</a:t>
-            </a:r>
-          </a:p>
-        </p:txBody>
-      </p:sp>
-      <p:sp>
-        <p:nvSpPr>
-          <p:cNvPr id="20" name="Row 4 time"/>
-          <p:cNvSpPr txBox="1"/>
-          <p:nvPr/>
-        </p:nvSpPr>
-        <p:spPr>
-          <a:xfrm>
-            <a:off x="8718691" y="6184387"/>
-            <a:ext cx="882509" cy="591788"/>
-          </a:xfrm>
-          <a:prstGeom prst="rect">
-            <a:avLst/>
-          </a:prstGeom>
-          <a:noFill/>
-        </p:spPr>
-        <p:txBody>
-          <a:bodyPr wrap="none" lIns="0" rIns="0" tIns="0" bIns="0" anchor="t">
-            <a:spAutoFit/>
-          </a:bodyPr>
-          <a:lstStyle/>
-          <a:p>
-            <a:pPr algn="r"/>
-            <a:r>
-              <a:rPr sz="2850" b="1">
-                <a:solidFill>
-                  <a:srgbClr val="F5EAD5"/>
-                </a:solidFill>
-                <a:latin typeface="Saira"/>
-              </a:rPr>
-              <a:t>7:30</a:t>
-            </a:r>
-          </a:p>
-        </p:txBody>
-      </p:sp>
-      <p:sp>
-        <p:nvSpPr>
-          <p:cNvPr id="21" name="Row 5 date panel"/>
-          <p:cNvSpPr/>
-          <p:nvPr/>
-        </p:nvSpPr>
-        <p:spPr>
-          <a:xfrm>
-            <a:off x="685800" y="7267575"/>
-            <a:ext cx="1422426" cy="716042"/>
-          </a:xfrm>
-          <a:custGeom>
-            <a:avLst/>
-            <a:gdLst/>
-            <a:ahLst/>
-            <a:cxnLst/>
-            <a:rect l="l" t="t" r="r" b="b"/>
-            <a:pathLst>
-              <a:path w="1422426" h="716042">
-                <a:moveTo>
-                  <a:pt x="85925" y="0"/>
-                </a:moveTo>
-                <a:lnTo>
-                  <a:pt x="1422426" y="0"/>
-                </a:lnTo>
-                <a:lnTo>
-                  <a:pt x="1336501" y="716042"/>
-                </a:lnTo>
-                <a:lnTo>
-                  <a:pt x="0" y="716042"/>
-                </a:lnTo>
-                <a:lnTo>
-                  <a:pt x="85925" y="0"/>
-                </a:lnTo>
-                <a:close/>
-              </a:path>
-            </a:pathLst>
-          </a:custGeom>
-          <a:solidFill>
-            <a:srgbClr val="F5EAD5"/>
-          </a:solidFill>
-          <a:ln>
-            <a:noFill/>
-          </a:ln>
-        </p:spPr>
-        <p:style>
-          <a:lnRef idx="1">
-            <a:schemeClr val="accent1"/>
-          </a:lnRef>
-          <a:fillRef idx="3">
-            <a:schemeClr val="accent1"/>
-          </a:fillRef>
-          <a:effectRef idx="2">
-            <a:schemeClr val="accent1"/>
-          </a:effectRef>
-          <a:fontRef idx="minor">
-            <a:schemeClr val="lt1"/>
-          </a:fontRef>
-        </p:style>
-        <p:txBody>
-          <a:bodyPr rtlCol="0" anchor="ctr"/>
-          <a:lstStyle/>
-          <a:p>
-            <a:pPr algn="ctr"/>
-          </a:p>
-        </p:txBody>
-      </p:sp>
-      <p:sp>
-        <p:nvSpPr>
-          <p:cNvPr id="22" name="Row 5 date"/>
-          <p:cNvSpPr txBox="1"/>
-          <p:nvPr/>
-        </p:nvSpPr>
-        <p:spPr>
-          <a:xfrm>
-            <a:off x="850490" y="7098722"/>
-            <a:ext cx="1212968" cy="1089050"/>
-          </a:xfrm>
-          <a:prstGeom prst="rect">
-            <a:avLst/>
-          </a:prstGeom>
-          <a:noFill/>
-        </p:spPr>
-        <p:txBody>
-          <a:bodyPr wrap="none" lIns="0" rIns="0" tIns="0" bIns="0" anchor="t">
-            <a:spAutoFit/>
-          </a:bodyPr>
-          <a:lstStyle/>
-          <a:p>
-            <a:pPr algn="l"/>
-            <a:r>
-              <a:rPr sz="5244" b="0" cap="all">
-                <a:solidFill>
-                  <a:srgbClr val="5E1A1D"/>
-                </a:solidFill>
-                <a:latin typeface="Saira Condensed Black"/>
-              </a:rPr>
-              <a:t>9/19</a:t>
-            </a:r>
-          </a:p>
-        </p:txBody>
-      </p:sp>
-      <p:sp>
-        <p:nvSpPr>
-          <p:cNvPr id="23" name="Row 5 opponent"/>
-          <p:cNvSpPr txBox="1"/>
-          <p:nvPr/>
-        </p:nvSpPr>
-        <p:spPr>
-          <a:xfrm>
-            <a:off x="2615915" y="7324225"/>
-            <a:ext cx="5921929" cy="622935"/>
-          </a:xfrm>
-          <a:prstGeom prst="rect">
-            <a:avLst/>
-          </a:prstGeom>
-          <a:noFill/>
-        </p:spPr>
-        <p:txBody>
-          <a:bodyPr wrap="none" lIns="0" rIns="0" tIns="0" bIns="0" anchor="t">
-            <a:spAutoFit/>
-          </a:bodyPr>
-          <a:lstStyle/>
-          <a:p>
-            <a:pPr algn="l"/>
-            <a:r>
-              <a:rPr sz="3000" b="1">
-                <a:solidFill>
-                  <a:srgbClr val="F5EAD5"/>
-                </a:solidFill>
-                <a:latin typeface="Saira"/>
-              </a:rPr>
-              <a:t>vs. Greenwood Christian School</a:t>
-            </a:r>
-          </a:p>
-        </p:txBody>
-      </p:sp>
-      <p:sp>
-        <p:nvSpPr>
-          <p:cNvPr id="24" name="Row 5 time"/>
-          <p:cNvSpPr txBox="1"/>
-          <p:nvPr/>
-        </p:nvSpPr>
-        <p:spPr>
-          <a:xfrm>
-            <a:off x="8718691" y="7339293"/>
-            <a:ext cx="882509" cy="591788"/>
-          </a:xfrm>
-          <a:prstGeom prst="rect">
-            <a:avLst/>
-          </a:prstGeom>
-          <a:noFill/>
-        </p:spPr>
-        <p:txBody>
-          <a:bodyPr wrap="none" lIns="0" rIns="0" tIns="0" bIns="0" anchor="t">
-            <a:spAutoFit/>
-          </a:bodyPr>
-          <a:lstStyle/>
-          <a:p>
-            <a:pPr algn="r"/>
-            <a:r>
-              <a:rPr sz="2850" b="1">
-                <a:solidFill>
-                  <a:srgbClr val="F5EAD5"/>
-                </a:solidFill>
-                <a:latin typeface="Saira"/>
-              </a:rPr>
-              <a:t>7:30</a:t>
-            </a:r>
-          </a:p>
-        </p:txBody>
-      </p:sp>
-      <p:sp>
-        <p:nvSpPr>
-          <p:cNvPr id="25" name="Row 6 date panel"/>
-          <p:cNvSpPr/>
-          <p:nvPr/>
-        </p:nvSpPr>
-        <p:spPr>
-          <a:xfrm>
-            <a:off x="685800" y="8422481"/>
-            <a:ext cx="1513013" cy="716042"/>
-          </a:xfrm>
-          <a:custGeom>
-            <a:avLst/>
-            <a:gdLst/>
-            <a:ahLst/>
-            <a:cxnLst/>
-            <a:rect l="l" t="t" r="r" b="b"/>
-            <a:pathLst>
-              <a:path w="1513013" h="716042">
-                <a:moveTo>
-                  <a:pt x="85925" y="0"/>
-                </a:moveTo>
-                <a:lnTo>
-                  <a:pt x="1513013" y="0"/>
-                </a:lnTo>
-                <a:lnTo>
-                  <a:pt x="1427088" y="716042"/>
-                </a:lnTo>
-                <a:lnTo>
-                  <a:pt x="0" y="716042"/>
-                </a:lnTo>
-                <a:lnTo>
-                  <a:pt x="85925" y="0"/>
-                </a:lnTo>
-                <a:close/>
-              </a:path>
-            </a:pathLst>
-          </a:custGeom>
-          <a:solidFill>
-            <a:srgbClr val="320B0B"/>
-          </a:solidFill>
-          <a:ln>
-            <a:noFill/>
-          </a:ln>
-        </p:spPr>
-        <p:style>
-          <a:lnRef idx="1">
-            <a:schemeClr val="accent1"/>
-          </a:lnRef>
-          <a:fillRef idx="3">
-            <a:schemeClr val="accent1"/>
-          </a:fillRef>
-          <a:effectRef idx="2">
-            <a:schemeClr val="accent1"/>
-          </a:effectRef>
-          <a:fontRef idx="minor">
-            <a:schemeClr val="lt1"/>
-          </a:fontRef>
-        </p:style>
-        <p:txBody>
-          <a:bodyPr rtlCol="0" anchor="ctr"/>
-          <a:lstStyle/>
-          <a:p>
-            <a:pPr algn="ctr"/>
-          </a:p>
-        </p:txBody>
-      </p:sp>
-      <p:sp>
-        <p:nvSpPr>
-          <p:cNvPr id="26" name="Row 6 date"/>
-          <p:cNvSpPr txBox="1"/>
-          <p:nvPr/>
-        </p:nvSpPr>
-        <p:spPr>
-          <a:xfrm>
-            <a:off x="850490" y="8253629"/>
-            <a:ext cx="1307179" cy="1089050"/>
-          </a:xfrm>
-          <a:prstGeom prst="rect">
-            <a:avLst/>
-          </a:prstGeom>
-          <a:noFill/>
-        </p:spPr>
-        <p:txBody>
-          <a:bodyPr wrap="none" lIns="0" rIns="0" tIns="0" bIns="0" anchor="t">
-            <a:spAutoFit/>
-          </a:bodyPr>
-          <a:lstStyle/>
-          <a:p>
-            <a:pPr algn="l"/>
-            <a:r>
-              <a:rPr sz="5244" b="0" cap="all">
-                <a:solidFill>
-                  <a:srgbClr val="EBD9C6"/>
-                </a:solidFill>
-                <a:latin typeface="Saira Condensed Black"/>
-              </a:rPr>
-              <a:t>9/26</a:t>
-            </a:r>
-          </a:p>
-        </p:txBody>
-      </p:sp>
-      <p:sp>
-        <p:nvSpPr>
-          <p:cNvPr id="27" name="Row 6 opponent"/>
-          <p:cNvSpPr txBox="1"/>
-          <p:nvPr/>
-        </p:nvSpPr>
-        <p:spPr>
-          <a:xfrm>
-            <a:off x="2615915" y="8479131"/>
-            <a:ext cx="1975775" cy="622935"/>
+            <a:off x="5097212" y="6886552"/>
+            <a:ext cx="2100194" cy="622935"/>
           </a:xfrm>
           <a:prstGeom prst="rect">
             <a:avLst/>
@@ -8486,88 +9410,21 @@
                 </a:solidFill>
                 <a:latin typeface="Saira"/>
               </a:rPr>
-              <a:t>Open date</a:t>
-            </a:r>
-          </a:p>
-        </p:txBody>
-      </p:sp>
-      <p:sp>
-        <p:nvSpPr>
-          <p:cNvPr id="28" name="Row 7 date panel"/>
-          <p:cNvSpPr/>
-          <p:nvPr/>
-        </p:nvSpPr>
-        <p:spPr>
-          <a:xfrm>
-            <a:off x="685800" y="9577388"/>
-            <a:ext cx="1403109" cy="716042"/>
-          </a:xfrm>
-          <a:custGeom>
-            <a:avLst/>
-            <a:gdLst/>
-            <a:ahLst/>
-            <a:cxnLst/>
-            <a:rect l="l" t="t" r="r" b="b"/>
-            <a:pathLst>
-              <a:path w="1403109" h="716042">
-                <a:moveTo>
-                  <a:pt x="85925" y="0"/>
-                </a:moveTo>
-                <a:lnTo>
-                  <a:pt x="1403109" y="0"/>
-                </a:lnTo>
-                <a:lnTo>
-                  <a:pt x="1317184" y="716042"/>
-                </a:lnTo>
-                <a:lnTo>
-                  <a:pt x="0" y="716042"/>
-                </a:lnTo>
-                <a:lnTo>
-                  <a:pt x="85925" y="0"/>
-                </a:lnTo>
-                <a:close/>
-              </a:path>
-            </a:pathLst>
-          </a:custGeom>
-          <a:solidFill>
-            <a:srgbClr val="F5EAD5"/>
-          </a:solidFill>
-          <a:ln>
-            <a:noFill/>
-          </a:ln>
-        </p:spPr>
-        <p:style>
-          <a:lnRef idx="1">
-            <a:schemeClr val="accent1"/>
-          </a:lnRef>
-          <a:fillRef idx="3">
-            <a:schemeClr val="accent1"/>
-          </a:fillRef>
-          <a:effectRef idx="2">
-            <a:schemeClr val="accent1"/>
-          </a:effectRef>
-          <a:fontRef idx="minor">
-            <a:schemeClr val="lt1"/>
-          </a:fontRef>
-        </p:style>
-        <p:txBody>
-          <a:bodyPr rtlCol="0" anchor="ctr"/>
-          <a:lstStyle/>
-          <a:p>
-            <a:pPr algn="ctr"/>
-          </a:p>
-        </p:txBody>
-      </p:sp>
-      <p:sp>
-        <p:nvSpPr>
-          <p:cNvPr id="29" name="Row 7 date"/>
+              <a:t>McCormick</a:t>
+            </a:r>
+          </a:p>
+        </p:txBody>
+      </p:sp>
+      <p:sp>
+        <p:nvSpPr>
+          <p:cNvPr id="12" name="Note"/>
           <p:cNvSpPr txBox="1"/>
           <p:nvPr/>
         </p:nvSpPr>
         <p:spPr>
           <a:xfrm>
-            <a:off x="850490" y="9408535"/>
-            <a:ext cx="1192879" cy="1089050"/>
+            <a:off x="685800" y="7710845"/>
+            <a:ext cx="1719130" cy="560642"/>
           </a:xfrm>
           <a:prstGeom prst="rect">
             <a:avLst/>
@@ -8582,255 +9439,13 @@
           <a:p>
             <a:pPr algn="l"/>
             <a:r>
-              <a:rPr sz="5244" b="0" cap="all">
+              <a:rPr sz="2700" b="0">
                 <a:solidFill>
-                  <a:srgbClr val="5E1A1D"/>
-                </a:solidFill>
-                <a:latin typeface="Saira Condensed Black"/>
-              </a:rPr>
-              <a:t>10/3</a:t>
-            </a:r>
-          </a:p>
-        </p:txBody>
-      </p:sp>
-      <p:sp>
-        <p:nvSpPr>
-          <p:cNvPr id="30" name="Row 7 opponent"/>
-          <p:cNvSpPr txBox="1"/>
-          <p:nvPr/>
-        </p:nvSpPr>
-        <p:spPr>
-          <a:xfrm>
-            <a:off x="2615915" y="9634037"/>
-            <a:ext cx="4443161" cy="622935"/>
-          </a:xfrm>
-          <a:prstGeom prst="rect">
-            <a:avLst/>
-          </a:prstGeom>
-          <a:noFill/>
-        </p:spPr>
-        <p:txBody>
-          <a:bodyPr wrap="none" lIns="0" rIns="0" tIns="0" bIns="0" anchor="t">
-            <a:spAutoFit/>
-          </a:bodyPr>
-          <a:lstStyle/>
-          <a:p>
-            <a:pPr algn="l"/>
-            <a:r>
-              <a:rPr sz="3000" b="1">
-                <a:solidFill>
-                  <a:srgbClr val="F5EAD5"/>
+                  <a:srgbClr val="EBD9C6"/>
                 </a:solidFill>
                 <a:latin typeface="Saira"/>
               </a:rPr>
-              <a:t>vs. Dixie (Homecoming)</a:t>
-            </a:r>
-          </a:p>
-        </p:txBody>
-      </p:sp>
-      <p:sp>
-        <p:nvSpPr>
-          <p:cNvPr id="31" name="Row 7 time"/>
-          <p:cNvSpPr txBox="1"/>
-          <p:nvPr/>
-        </p:nvSpPr>
-        <p:spPr>
-          <a:xfrm>
-            <a:off x="8718691" y="9649106"/>
-            <a:ext cx="882509" cy="591788"/>
-          </a:xfrm>
-          <a:prstGeom prst="rect">
-            <a:avLst/>
-          </a:prstGeom>
-          <a:noFill/>
-        </p:spPr>
-        <p:txBody>
-          <a:bodyPr wrap="none" lIns="0" rIns="0" tIns="0" bIns="0" anchor="t">
-            <a:spAutoFit/>
-          </a:bodyPr>
-          <a:lstStyle/>
-          <a:p>
-            <a:pPr algn="r"/>
-            <a:r>
-              <a:rPr sz="2850" b="1">
-                <a:solidFill>
-                  <a:srgbClr val="F5EAD5"/>
-                </a:solidFill>
-                <a:latin typeface="Saira"/>
-              </a:rPr>
-              <a:t>7:30</a:t>
-            </a:r>
-          </a:p>
-        </p:txBody>
-      </p:sp>
-      <p:sp>
-        <p:nvSpPr>
-          <p:cNvPr id="32" name="Row 8 date panel"/>
-          <p:cNvSpPr/>
-          <p:nvPr/>
-        </p:nvSpPr>
-        <p:spPr>
-          <a:xfrm>
-            <a:off x="685800" y="10732294"/>
-            <a:ext cx="1642234" cy="716042"/>
-          </a:xfrm>
-          <a:custGeom>
-            <a:avLst/>
-            <a:gdLst/>
-            <a:ahLst/>
-            <a:cxnLst/>
-            <a:rect l="l" t="t" r="r" b="b"/>
-            <a:pathLst>
-              <a:path w="1642234" h="716042">
-                <a:moveTo>
-                  <a:pt x="85925" y="0"/>
-                </a:moveTo>
-                <a:lnTo>
-                  <a:pt x="1642234" y="0"/>
-                </a:lnTo>
-                <a:lnTo>
-                  <a:pt x="1556309" y="716042"/>
-                </a:lnTo>
-                <a:lnTo>
-                  <a:pt x="0" y="716042"/>
-                </a:lnTo>
-                <a:lnTo>
-                  <a:pt x="85925" y="0"/>
-                </a:lnTo>
-                <a:close/>
-              </a:path>
-            </a:pathLst>
-          </a:custGeom>
-          <a:solidFill>
-            <a:srgbClr val="F5EAD5"/>
-          </a:solidFill>
-          <a:ln>
-            <a:noFill/>
-          </a:ln>
-        </p:spPr>
-        <p:style>
-          <a:lnRef idx="1">
-            <a:schemeClr val="accent1"/>
-          </a:lnRef>
-          <a:fillRef idx="3">
-            <a:schemeClr val="accent1"/>
-          </a:fillRef>
-          <a:effectRef idx="2">
-            <a:schemeClr val="accent1"/>
-          </a:effectRef>
-          <a:fontRef idx="minor">
-            <a:schemeClr val="lt1"/>
-          </a:fontRef>
-        </p:style>
-        <p:txBody>
-          <a:bodyPr rtlCol="0" anchor="ctr"/>
-          <a:lstStyle/>
-          <a:p>
-            <a:pPr algn="ctr"/>
-          </a:p>
-        </p:txBody>
-      </p:sp>
-      <p:sp>
-        <p:nvSpPr>
-          <p:cNvPr id="33" name="Row 8 date"/>
-          <p:cNvSpPr txBox="1"/>
-          <p:nvPr/>
-        </p:nvSpPr>
-        <p:spPr>
-          <a:xfrm>
-            <a:off x="850490" y="10563441"/>
-            <a:ext cx="1441569" cy="1089050"/>
-          </a:xfrm>
-          <a:prstGeom prst="rect">
-            <a:avLst/>
-          </a:prstGeom>
-          <a:noFill/>
-        </p:spPr>
-        <p:txBody>
-          <a:bodyPr wrap="none" lIns="0" rIns="0" tIns="0" bIns="0" anchor="t">
-            <a:spAutoFit/>
-          </a:bodyPr>
-          <a:lstStyle/>
-          <a:p>
-            <a:pPr algn="l"/>
-            <a:r>
-              <a:rPr sz="5244" b="0" cap="all">
-                <a:solidFill>
-                  <a:srgbClr val="5E1A1D"/>
-                </a:solidFill>
-                <a:latin typeface="Saira Condensed Black"/>
-              </a:rPr>
-              <a:t>10/10</a:t>
-            </a:r>
-          </a:p>
-        </p:txBody>
-      </p:sp>
-      <p:sp>
-        <p:nvSpPr>
-          <p:cNvPr id="34" name="Row 8 opponent"/>
-          <p:cNvSpPr txBox="1"/>
-          <p:nvPr/>
-        </p:nvSpPr>
-        <p:spPr>
-          <a:xfrm>
-            <a:off x="2615915" y="10788944"/>
-            <a:ext cx="5937778" cy="622935"/>
-          </a:xfrm>
-          <a:prstGeom prst="rect">
-            <a:avLst/>
-          </a:prstGeom>
-          <a:noFill/>
-        </p:spPr>
-        <p:txBody>
-          <a:bodyPr wrap="none" lIns="0" rIns="0" tIns="0" bIns="0" anchor="t">
-            <a:spAutoFit/>
-          </a:bodyPr>
-          <a:lstStyle/>
-          <a:p>
-            <a:pPr algn="l"/>
-            <a:r>
-              <a:rPr sz="3000" b="1">
-                <a:solidFill>
-                  <a:srgbClr val="F5EAD5"/>
-                </a:solidFill>
-                <a:latin typeface="Saira"/>
-              </a:rPr>
-              <a:t>at Region tournament, site TBA</a:t>
-            </a:r>
-          </a:p>
-        </p:txBody>
-      </p:sp>
-      <p:sp>
-        <p:nvSpPr>
-          <p:cNvPr id="35" name="Row 8 time"/>
-          <p:cNvSpPr txBox="1"/>
-          <p:nvPr/>
-        </p:nvSpPr>
-        <p:spPr>
-          <a:xfrm>
-            <a:off x="8792095" y="10804012"/>
-            <a:ext cx="809105" cy="591788"/>
-          </a:xfrm>
-          <a:prstGeom prst="rect">
-            <a:avLst/>
-          </a:prstGeom>
-          <a:noFill/>
-        </p:spPr>
-        <p:txBody>
-          <a:bodyPr wrap="none" lIns="0" rIns="0" tIns="0" bIns="0" anchor="t">
-            <a:spAutoFit/>
-          </a:bodyPr>
-          <a:lstStyle/>
-          <a:p>
-            <a:pPr algn="r"/>
-            <a:r>
-              <a:rPr sz="2850" b="1">
-                <a:solidFill>
-                  <a:srgbClr val="F5EAD5"/>
-                </a:solidFill>
-                <a:latin typeface="Saira"/>
-              </a:rPr>
-              <a:t>TBA</a:t>
+              <a:t>Final, 2OT</a:t>
             </a:r>
           </a:p>
         </p:txBody>

</xml_diff>